<commit_message>
updates to early slides
</commit_message>
<xml_diff>
--- a/slides/01_what_is_ml.pptx
+++ b/slides/01_what_is_ml.pptx
@@ -5,17 +5,19 @@
     <p:sldMasterId id="2147483648" r:id="rId1"/>
   </p:sldMasterIdLst>
   <p:notesMasterIdLst>
-    <p:notesMasterId r:id="rId10"/>
+    <p:notesMasterId r:id="rId12"/>
   </p:notesMasterIdLst>
   <p:sldIdLst>
     <p:sldId id="256" r:id="rId2"/>
     <p:sldId id="257" r:id="rId3"/>
-    <p:sldId id="258" r:id="rId4"/>
-    <p:sldId id="259" r:id="rId5"/>
-    <p:sldId id="260" r:id="rId6"/>
-    <p:sldId id="261" r:id="rId7"/>
-    <p:sldId id="262" r:id="rId8"/>
-    <p:sldId id="263" r:id="rId9"/>
+    <p:sldId id="264" r:id="rId4"/>
+    <p:sldId id="265" r:id="rId5"/>
+    <p:sldId id="266" r:id="rId6"/>
+    <p:sldId id="259" r:id="rId7"/>
+    <p:sldId id="260" r:id="rId8"/>
+    <p:sldId id="261" r:id="rId9"/>
+    <p:sldId id="262" r:id="rId10"/>
+    <p:sldId id="263" r:id="rId11"/>
   </p:sldIdLst>
   <p:sldSz cx="12192000" cy="6858000"/>
   <p:notesSz cx="6858000" cy="9144000"/>
@@ -114,6 +116,11 @@
       </a:defRPr>
     </a:lvl9pPr>
   </p:defaultTextStyle>
+  <p:extLst>
+    <p:ext uri="{EFAFB233-063F-42B5-8137-9DF3F51BA10A}">
+      <p15:sldGuideLst xmlns:p15="http://schemas.microsoft.com/office/powerpoint/2012/main"/>
+    </p:ext>
+  </p:extLst>
 </p:presentation>
 </file>
 
@@ -199,7 +206,7 @@
           <a:p>
             <a:fld id="{DA3B5F47-542D-2F4A-A589-8990110BEF85}" type="datetimeFigureOut">
               <a:rPr lang="en-US" smtClean="0"/>
-              <a:t>3/30/26</a:t>
+              <a:t>3/31/26</a:t>
             </a:fld>
             <a:endParaRPr lang="en-US"/>
           </a:p>
@@ -561,6 +568,244 @@
 </p:notes>
 </file>
 
+<file path=ppt/notesSlides/notesSlide2.xml><?xml version="1.0" encoding="utf-8"?>
+<p:notes xmlns:a="http://schemas.openxmlformats.org/drawingml/2006/main" xmlns:r="http://schemas.openxmlformats.org/officeDocument/2006/relationships" xmlns:p="http://schemas.openxmlformats.org/presentationml/2006/main">
+  <p:cSld>
+    <p:spTree>
+      <p:nvGrpSpPr>
+        <p:cNvPr id="1" name="">
+          <a:extLst>
+            <a:ext uri="{FF2B5EF4-FFF2-40B4-BE49-F238E27FC236}">
+              <a16:creationId xmlns:a16="http://schemas.microsoft.com/office/drawing/2014/main" id="{3F25C84D-0C20-A2DC-6291-38E80B768035}"/>
+            </a:ext>
+          </a:extLst>
+        </p:cNvPr>
+        <p:cNvGrpSpPr/>
+        <p:nvPr/>
+      </p:nvGrpSpPr>
+      <p:grpSpPr>
+        <a:xfrm>
+          <a:off x="0" y="0"/>
+          <a:ext cx="0" cy="0"/>
+          <a:chOff x="0" y="0"/>
+          <a:chExt cx="0" cy="0"/>
+        </a:xfrm>
+      </p:grpSpPr>
+      <p:sp>
+        <p:nvSpPr>
+          <p:cNvPr id="2" name="Slide Image Placeholder 1">
+            <a:extLst>
+              <a:ext uri="{FF2B5EF4-FFF2-40B4-BE49-F238E27FC236}">
+                <a16:creationId xmlns:a16="http://schemas.microsoft.com/office/drawing/2014/main" id="{52050D61-204D-DD3C-F48C-27625251A884}"/>
+              </a:ext>
+            </a:extLst>
+          </p:cNvPr>
+          <p:cNvSpPr>
+            <a:spLocks noGrp="1" noRot="1" noChangeAspect="1"/>
+          </p:cNvSpPr>
+          <p:nvPr>
+            <p:ph type="sldImg"/>
+          </p:nvPr>
+        </p:nvSpPr>
+        <p:spPr/>
+      </p:sp>
+      <p:sp>
+        <p:nvSpPr>
+          <p:cNvPr id="3" name="Notes Placeholder 2">
+            <a:extLst>
+              <a:ext uri="{FF2B5EF4-FFF2-40B4-BE49-F238E27FC236}">
+                <a16:creationId xmlns:a16="http://schemas.microsoft.com/office/drawing/2014/main" id="{7D48D780-E676-5074-2C7F-C24D41406414}"/>
+              </a:ext>
+            </a:extLst>
+          </p:cNvPr>
+          <p:cNvSpPr>
+            <a:spLocks noGrp="1"/>
+          </p:cNvSpPr>
+          <p:nvPr>
+            <p:ph type="body" idx="1"/>
+          </p:nvPr>
+        </p:nvSpPr>
+        <p:spPr/>
+        <p:txBody>
+          <a:bodyPr/>
+          <a:lstStyle/>
+          <a:p>
+            <a:r>
+              <a:rPr lang="en-US" dirty="0"/>
+              <a:t>[Molnar, C. Modeling mindsets: the many cultures of learning from data.](https://</a:t>
+            </a:r>
+            <a:r>
+              <a:rPr lang="en-US" dirty="0" err="1"/>
+              <a:t>christophmolnar.com</a:t>
+            </a:r>
+            <a:r>
+              <a:rPr lang="en-US" dirty="0"/>
+              <a:t>/books/modeling-mindsets)</a:t>
+            </a:r>
+          </a:p>
+        </p:txBody>
+      </p:sp>
+      <p:sp>
+        <p:nvSpPr>
+          <p:cNvPr id="4" name="Slide Number Placeholder 3">
+            <a:extLst>
+              <a:ext uri="{FF2B5EF4-FFF2-40B4-BE49-F238E27FC236}">
+                <a16:creationId xmlns:a16="http://schemas.microsoft.com/office/drawing/2014/main" id="{57CFE9F0-67FE-1A05-CA34-1E523B480A45}"/>
+              </a:ext>
+            </a:extLst>
+          </p:cNvPr>
+          <p:cNvSpPr>
+            <a:spLocks noGrp="1"/>
+          </p:cNvSpPr>
+          <p:nvPr>
+            <p:ph type="sldNum" sz="quarter" idx="5"/>
+          </p:nvPr>
+        </p:nvSpPr>
+        <p:spPr/>
+        <p:txBody>
+          <a:bodyPr/>
+          <a:lstStyle/>
+          <a:p>
+            <a:fld id="{51D417A5-630B-DE42-860C-96747A2C59DE}" type="slidenum">
+              <a:rPr lang="en-US" smtClean="0"/>
+              <a:t>3</a:t>
+            </a:fld>
+            <a:endParaRPr lang="en-US"/>
+          </a:p>
+        </p:txBody>
+      </p:sp>
+    </p:spTree>
+    <p:extLst>
+      <p:ext uri="{BB962C8B-B14F-4D97-AF65-F5344CB8AC3E}">
+        <p14:creationId xmlns:p14="http://schemas.microsoft.com/office/powerpoint/2010/main" val="2140901328"/>
+      </p:ext>
+    </p:extLst>
+  </p:cSld>
+  <p:clrMapOvr>
+    <a:masterClrMapping/>
+  </p:clrMapOvr>
+</p:notes>
+</file>
+
+<file path=ppt/notesSlides/notesSlide3.xml><?xml version="1.0" encoding="utf-8"?>
+<p:notes xmlns:a="http://schemas.openxmlformats.org/drawingml/2006/main" xmlns:r="http://schemas.openxmlformats.org/officeDocument/2006/relationships" xmlns:p="http://schemas.openxmlformats.org/presentationml/2006/main">
+  <p:cSld>
+    <p:spTree>
+      <p:nvGrpSpPr>
+        <p:cNvPr id="1" name="">
+          <a:extLst>
+            <a:ext uri="{FF2B5EF4-FFF2-40B4-BE49-F238E27FC236}">
+              <a16:creationId xmlns:a16="http://schemas.microsoft.com/office/drawing/2014/main" id="{D4550BB0-497A-39B7-EA28-1E35775854C0}"/>
+            </a:ext>
+          </a:extLst>
+        </p:cNvPr>
+        <p:cNvGrpSpPr/>
+        <p:nvPr/>
+      </p:nvGrpSpPr>
+      <p:grpSpPr>
+        <a:xfrm>
+          <a:off x="0" y="0"/>
+          <a:ext cx="0" cy="0"/>
+          <a:chOff x="0" y="0"/>
+          <a:chExt cx="0" cy="0"/>
+        </a:xfrm>
+      </p:grpSpPr>
+      <p:sp>
+        <p:nvSpPr>
+          <p:cNvPr id="2" name="Slide Image Placeholder 1">
+            <a:extLst>
+              <a:ext uri="{FF2B5EF4-FFF2-40B4-BE49-F238E27FC236}">
+                <a16:creationId xmlns:a16="http://schemas.microsoft.com/office/drawing/2014/main" id="{5ED50DAC-95E3-F24C-D7A3-888E902232C9}"/>
+              </a:ext>
+            </a:extLst>
+          </p:cNvPr>
+          <p:cNvSpPr>
+            <a:spLocks noGrp="1" noRot="1" noChangeAspect="1"/>
+          </p:cNvSpPr>
+          <p:nvPr>
+            <p:ph type="sldImg"/>
+          </p:nvPr>
+        </p:nvSpPr>
+        <p:spPr/>
+      </p:sp>
+      <p:sp>
+        <p:nvSpPr>
+          <p:cNvPr id="3" name="Notes Placeholder 2">
+            <a:extLst>
+              <a:ext uri="{FF2B5EF4-FFF2-40B4-BE49-F238E27FC236}">
+                <a16:creationId xmlns:a16="http://schemas.microsoft.com/office/drawing/2014/main" id="{25E8B883-13C4-2B1F-51D0-4AE9811193ED}"/>
+              </a:ext>
+            </a:extLst>
+          </p:cNvPr>
+          <p:cNvSpPr>
+            <a:spLocks noGrp="1"/>
+          </p:cNvSpPr>
+          <p:nvPr>
+            <p:ph type="body" idx="1"/>
+          </p:nvPr>
+        </p:nvSpPr>
+        <p:spPr/>
+        <p:txBody>
+          <a:bodyPr/>
+          <a:lstStyle/>
+          <a:p>
+            <a:r>
+              <a:rPr lang="en-US" dirty="0"/>
+              <a:t>[Molnar, C. Modeling mindsets: the many cultures of learning from data.](https://</a:t>
+            </a:r>
+            <a:r>
+              <a:rPr lang="en-US" dirty="0" err="1"/>
+              <a:t>christophmolnar.com</a:t>
+            </a:r>
+            <a:r>
+              <a:rPr lang="en-US" dirty="0"/>
+              <a:t>/books/modeling-mindsets)</a:t>
+            </a:r>
+          </a:p>
+        </p:txBody>
+      </p:sp>
+      <p:sp>
+        <p:nvSpPr>
+          <p:cNvPr id="4" name="Slide Number Placeholder 3">
+            <a:extLst>
+              <a:ext uri="{FF2B5EF4-FFF2-40B4-BE49-F238E27FC236}">
+                <a16:creationId xmlns:a16="http://schemas.microsoft.com/office/drawing/2014/main" id="{AE4B44BE-4C44-B3F2-3013-B1BFCFFA3F1F}"/>
+              </a:ext>
+            </a:extLst>
+          </p:cNvPr>
+          <p:cNvSpPr>
+            <a:spLocks noGrp="1"/>
+          </p:cNvSpPr>
+          <p:nvPr>
+            <p:ph type="sldNum" sz="quarter" idx="5"/>
+          </p:nvPr>
+        </p:nvSpPr>
+        <p:spPr/>
+        <p:txBody>
+          <a:bodyPr/>
+          <a:lstStyle/>
+          <a:p>
+            <a:fld id="{51D417A5-630B-DE42-860C-96747A2C59DE}" type="slidenum">
+              <a:rPr lang="en-US" smtClean="0"/>
+              <a:t>4</a:t>
+            </a:fld>
+            <a:endParaRPr lang="en-US"/>
+          </a:p>
+        </p:txBody>
+      </p:sp>
+    </p:spTree>
+    <p:extLst>
+      <p:ext uri="{BB962C8B-B14F-4D97-AF65-F5344CB8AC3E}">
+        <p14:creationId xmlns:p14="http://schemas.microsoft.com/office/powerpoint/2010/main" val="233797556"/>
+      </p:ext>
+    </p:extLst>
+  </p:cSld>
+  <p:clrMapOvr>
+    <a:masterClrMapping/>
+  </p:clrMapOvr>
+</p:notes>
+</file>
+
 <file path=ppt/slideLayouts/slideLayout1.xml><?xml version="1.0" encoding="utf-8"?>
 <p:sldLayout xmlns:a="http://schemas.openxmlformats.org/drawingml/2006/main" xmlns:r="http://schemas.openxmlformats.org/officeDocument/2006/relationships" xmlns:p="http://schemas.openxmlformats.org/presentationml/2006/main" type="title" preserve="1">
   <p:cSld name="Title Slide">
@@ -708,7 +953,7 @@
           <a:p>
             <a:fld id="{19EC6F6F-998C-264C-A700-8215E11AE5BD}" type="datetimeFigureOut">
               <a:rPr lang="en-US" smtClean="0"/>
-              <a:t>3/30/26</a:t>
+              <a:t>3/31/26</a:t>
             </a:fld>
             <a:endParaRPr lang="en-US"/>
           </a:p>
@@ -906,7 +1151,7 @@
           <a:p>
             <a:fld id="{19EC6F6F-998C-264C-A700-8215E11AE5BD}" type="datetimeFigureOut">
               <a:rPr lang="en-US" smtClean="0"/>
-              <a:t>3/30/26</a:t>
+              <a:t>3/31/26</a:t>
             </a:fld>
             <a:endParaRPr lang="en-US"/>
           </a:p>
@@ -1114,7 +1359,7 @@
           <a:p>
             <a:fld id="{19EC6F6F-998C-264C-A700-8215E11AE5BD}" type="datetimeFigureOut">
               <a:rPr lang="en-US" smtClean="0"/>
-              <a:t>3/30/26</a:t>
+              <a:t>3/31/26</a:t>
             </a:fld>
             <a:endParaRPr lang="en-US"/>
           </a:p>
@@ -1312,7 +1557,7 @@
           <a:p>
             <a:fld id="{19EC6F6F-998C-264C-A700-8215E11AE5BD}" type="datetimeFigureOut">
               <a:rPr lang="en-US" smtClean="0"/>
-              <a:t>3/30/26</a:t>
+              <a:t>3/31/26</a:t>
             </a:fld>
             <a:endParaRPr lang="en-US"/>
           </a:p>
@@ -1587,7 +1832,7 @@
           <a:p>
             <a:fld id="{19EC6F6F-998C-264C-A700-8215E11AE5BD}" type="datetimeFigureOut">
               <a:rPr lang="en-US" smtClean="0"/>
-              <a:t>3/30/26</a:t>
+              <a:t>3/31/26</a:t>
             </a:fld>
             <a:endParaRPr lang="en-US"/>
           </a:p>
@@ -1852,7 +2097,7 @@
           <a:p>
             <a:fld id="{19EC6F6F-998C-264C-A700-8215E11AE5BD}" type="datetimeFigureOut">
               <a:rPr lang="en-US" smtClean="0"/>
-              <a:t>3/30/26</a:t>
+              <a:t>3/31/26</a:t>
             </a:fld>
             <a:endParaRPr lang="en-US"/>
           </a:p>
@@ -2264,7 +2509,7 @@
           <a:p>
             <a:fld id="{19EC6F6F-998C-264C-A700-8215E11AE5BD}" type="datetimeFigureOut">
               <a:rPr lang="en-US" smtClean="0"/>
-              <a:t>3/30/26</a:t>
+              <a:t>3/31/26</a:t>
             </a:fld>
             <a:endParaRPr lang="en-US"/>
           </a:p>
@@ -2405,7 +2650,7 @@
           <a:p>
             <a:fld id="{19EC6F6F-998C-264C-A700-8215E11AE5BD}" type="datetimeFigureOut">
               <a:rPr lang="en-US" smtClean="0"/>
-              <a:t>3/30/26</a:t>
+              <a:t>3/31/26</a:t>
             </a:fld>
             <a:endParaRPr lang="en-US"/>
           </a:p>
@@ -2518,7 +2763,7 @@
           <a:p>
             <a:fld id="{19EC6F6F-998C-264C-A700-8215E11AE5BD}" type="datetimeFigureOut">
               <a:rPr lang="en-US" smtClean="0"/>
-              <a:t>3/30/26</a:t>
+              <a:t>3/31/26</a:t>
             </a:fld>
             <a:endParaRPr lang="en-US"/>
           </a:p>
@@ -2829,7 +3074,7 @@
           <a:p>
             <a:fld id="{19EC6F6F-998C-264C-A700-8215E11AE5BD}" type="datetimeFigureOut">
               <a:rPr lang="en-US" smtClean="0"/>
-              <a:t>3/30/26</a:t>
+              <a:t>3/31/26</a:t>
             </a:fld>
             <a:endParaRPr lang="en-US"/>
           </a:p>
@@ -3117,7 +3362,7 @@
           <a:p>
             <a:fld id="{19EC6F6F-998C-264C-A700-8215E11AE5BD}" type="datetimeFigureOut">
               <a:rPr lang="en-US" smtClean="0"/>
-              <a:t>3/30/26</a:t>
+              <a:t>3/31/26</a:t>
             </a:fld>
             <a:endParaRPr lang="en-US"/>
           </a:p>
@@ -3358,7 +3603,7 @@
           <a:p>
             <a:fld id="{19EC6F6F-998C-264C-A700-8215E11AE5BD}" type="datetimeFigureOut">
               <a:rPr lang="en-US" smtClean="0"/>
-              <a:t>3/30/26</a:t>
+              <a:t>3/31/26</a:t>
             </a:fld>
             <a:endParaRPr lang="en-US"/>
           </a:p>
@@ -4056,6 +4301,119 @@
 </p:sld>
 </file>
 
+<file path=ppt/slides/slide10.xml><?xml version="1.0" encoding="utf-8"?>
+<p:sld xmlns:a="http://schemas.openxmlformats.org/drawingml/2006/main" xmlns:r="http://schemas.openxmlformats.org/officeDocument/2006/relationships" xmlns:p="http://schemas.openxmlformats.org/presentationml/2006/main">
+  <p:cSld>
+    <p:spTree>
+      <p:nvGrpSpPr>
+        <p:cNvPr id="1" name=""/>
+        <p:cNvGrpSpPr/>
+        <p:nvPr/>
+      </p:nvGrpSpPr>
+      <p:grpSpPr>
+        <a:xfrm>
+          <a:off x="0" y="0"/>
+          <a:ext cx="0" cy="0"/>
+          <a:chOff x="0" y="0"/>
+          <a:chExt cx="0" cy="0"/>
+        </a:xfrm>
+      </p:grpSpPr>
+      <p:sp>
+        <p:nvSpPr>
+          <p:cNvPr id="2" name="Title 1">
+            <a:extLst>
+              <a:ext uri="{FF2B5EF4-FFF2-40B4-BE49-F238E27FC236}">
+                <a16:creationId xmlns:a16="http://schemas.microsoft.com/office/drawing/2014/main" id="{8F4609B2-8DAD-0237-B6AF-7CC64EAB54FC}"/>
+              </a:ext>
+            </a:extLst>
+          </p:cNvPr>
+          <p:cNvSpPr>
+            <a:spLocks noGrp="1"/>
+          </p:cNvSpPr>
+          <p:nvPr>
+            <p:ph type="title"/>
+          </p:nvPr>
+        </p:nvSpPr>
+        <p:spPr/>
+        <p:txBody>
+          <a:bodyPr/>
+          <a:lstStyle/>
+          <a:p>
+            <a:r>
+              <a:rPr lang="en-US" dirty="0"/>
+              <a:t>Break out groups (~5min)</a:t>
+            </a:r>
+          </a:p>
+        </p:txBody>
+      </p:sp>
+      <p:sp>
+        <p:nvSpPr>
+          <p:cNvPr id="3" name="Content Placeholder 2">
+            <a:extLst>
+              <a:ext uri="{FF2B5EF4-FFF2-40B4-BE49-F238E27FC236}">
+                <a16:creationId xmlns:a16="http://schemas.microsoft.com/office/drawing/2014/main" id="{29D0A7A8-6062-EB24-E8E3-40035D8AB20C}"/>
+              </a:ext>
+            </a:extLst>
+          </p:cNvPr>
+          <p:cNvSpPr>
+            <a:spLocks noGrp="1"/>
+          </p:cNvSpPr>
+          <p:nvPr>
+            <p:ph idx="1"/>
+          </p:nvPr>
+        </p:nvSpPr>
+        <p:spPr/>
+        <p:txBody>
+          <a:bodyPr/>
+          <a:lstStyle/>
+          <a:p>
+            <a:pPr marL="0" indent="0">
+              <a:buNone/>
+            </a:pPr>
+            <a:r>
+              <a:rPr lang="en-US" dirty="0"/>
+              <a:t>Talk with folks at your table:</a:t>
+            </a:r>
+          </a:p>
+          <a:p>
+            <a:r>
+              <a:rPr lang="en-US" dirty="0"/>
+              <a:t>Names</a:t>
+            </a:r>
+          </a:p>
+          <a:p>
+            <a:r>
+              <a:rPr lang="en-US" dirty="0"/>
+              <a:t>What modeling mindset(s) you typically use in your work</a:t>
+            </a:r>
+          </a:p>
+          <a:p>
+            <a:r>
+              <a:rPr lang="en-US" dirty="0"/>
+              <a:t>What interests brought you to this workshop today</a:t>
+            </a:r>
+          </a:p>
+          <a:p>
+            <a:r>
+              <a:rPr lang="en-US" dirty="0"/>
+              <a:t>Favorite body of water (anywhere, any type)</a:t>
+            </a:r>
+          </a:p>
+        </p:txBody>
+      </p:sp>
+    </p:spTree>
+    <p:extLst>
+      <p:ext uri="{BB962C8B-B14F-4D97-AF65-F5344CB8AC3E}">
+        <p14:creationId xmlns:p14="http://schemas.microsoft.com/office/powerpoint/2010/main" val="3850885334"/>
+      </p:ext>
+    </p:extLst>
+  </p:cSld>
+  <p:clrMapOvr>
+    <a:masterClrMapping/>
+  </p:clrMapOvr>
+</p:sld>
+</file>
+
 <file path=ppt/slides/slide2.xml><?xml version="1.0" encoding="utf-8"?>
 <p:sld xmlns:a="http://schemas.openxmlformats.org/drawingml/2006/main" xmlns:r="http://schemas.openxmlformats.org/officeDocument/2006/relationships" xmlns:p="http://schemas.openxmlformats.org/presentationml/2006/main">
   <p:cSld>
@@ -4103,31 +4461,6 @@
       </p:sp>
       <p:sp>
         <p:nvSpPr>
-          <p:cNvPr id="3" name="Content Placeholder 2">
-            <a:extLst>
-              <a:ext uri="{FF2B5EF4-FFF2-40B4-BE49-F238E27FC236}">
-                <a16:creationId xmlns:a16="http://schemas.microsoft.com/office/drawing/2014/main" id="{6F1E4FAB-9E73-A0A6-58B4-1C0E65E13163}"/>
-              </a:ext>
-            </a:extLst>
-          </p:cNvPr>
-          <p:cNvSpPr>
-            <a:spLocks noGrp="1"/>
-          </p:cNvSpPr>
-          <p:nvPr>
-            <p:ph idx="1"/>
-          </p:nvPr>
-        </p:nvSpPr>
-        <p:spPr/>
-        <p:txBody>
-          <a:bodyPr/>
-          <a:lstStyle/>
-          <a:p>
-            <a:endParaRPr lang="en-US"/>
-          </a:p>
-        </p:txBody>
-      </p:sp>
-      <p:sp>
-        <p:nvSpPr>
           <p:cNvPr id="5" name="TextBox 4">
             <a:extLst>
               <a:ext uri="{FF2B5EF4-FFF2-40B4-BE49-F238E27FC236}">
@@ -4164,6 +4497,36 @@
           </a:p>
         </p:txBody>
       </p:sp>
+      <p:pic>
+        <p:nvPicPr>
+          <p:cNvPr id="4" name="Picture 3">
+            <a:extLst>
+              <a:ext uri="{FF2B5EF4-FFF2-40B4-BE49-F238E27FC236}">
+                <a16:creationId xmlns:a16="http://schemas.microsoft.com/office/drawing/2014/main" id="{0ABBDEE9-B16A-2223-F62F-97D22547101D}"/>
+              </a:ext>
+            </a:extLst>
+          </p:cNvPr>
+          <p:cNvPicPr>
+            <a:picLocks noChangeAspect="1"/>
+          </p:cNvPicPr>
+          <p:nvPr/>
+        </p:nvPicPr>
+        <p:blipFill>
+          <a:blip r:embed="rId4"/>
+          <a:stretch>
+            <a:fillRect/>
+          </a:stretch>
+        </p:blipFill>
+        <p:spPr>
+          <a:xfrm>
+            <a:off x="2209800" y="1806291"/>
+            <a:ext cx="7772400" cy="4326071"/>
+          </a:xfrm>
+          <a:prstGeom prst="rect">
+            <a:avLst/>
+          </a:prstGeom>
+        </p:spPr>
+      </p:pic>
     </p:spTree>
     <p:extLst>
       <p:ext uri="{BB962C8B-B14F-4D97-AF65-F5344CB8AC3E}">
@@ -4182,7 +4545,13 @@
   <p:cSld>
     <p:spTree>
       <p:nvGrpSpPr>
-        <p:cNvPr id="1" name=""/>
+        <p:cNvPr id="1" name="">
+          <a:extLst>
+            <a:ext uri="{FF2B5EF4-FFF2-40B4-BE49-F238E27FC236}">
+              <a16:creationId xmlns:a16="http://schemas.microsoft.com/office/drawing/2014/main" id="{CA8E8A63-C13B-DD5A-494A-6824A88D347C}"/>
+            </a:ext>
+          </a:extLst>
+        </p:cNvPr>
         <p:cNvGrpSpPr/>
         <p:nvPr/>
       </p:nvGrpSpPr>
@@ -4199,7 +4568,7 @@
           <p:cNvPr id="2" name="Title 1">
             <a:extLst>
               <a:ext uri="{FF2B5EF4-FFF2-40B4-BE49-F238E27FC236}">
-                <a16:creationId xmlns:a16="http://schemas.microsoft.com/office/drawing/2014/main" id="{D3F06ABF-D6E3-1ED0-B803-50EFB5941D72}"/>
+                <a16:creationId xmlns:a16="http://schemas.microsoft.com/office/drawing/2014/main" id="{B2D0C150-6EFF-9243-ACB9-95EAABFEE49D}"/>
               </a:ext>
             </a:extLst>
           </p:cNvPr>
@@ -4217,40 +4586,181 @@
           <a:p>
             <a:r>
               <a:rPr lang="en-US" dirty="0"/>
-              <a:t>Machine learning – focused on prediction</a:t>
-            </a:r>
-          </a:p>
-        </p:txBody>
-      </p:sp>
-      <p:sp>
-        <p:nvSpPr>
-          <p:cNvPr id="3" name="Content Placeholder 2">
-            <a:extLst>
-              <a:ext uri="{FF2B5EF4-FFF2-40B4-BE49-F238E27FC236}">
-                <a16:creationId xmlns:a16="http://schemas.microsoft.com/office/drawing/2014/main" id="{4BF9CCD4-3651-5E47-93EC-79A46D8D7BD7}"/>
-              </a:ext>
-            </a:extLst>
-          </p:cNvPr>
-          <p:cNvSpPr>
-            <a:spLocks noGrp="1"/>
-          </p:cNvSpPr>
-          <p:nvPr>
-            <p:ph idx="1"/>
-          </p:nvPr>
-        </p:nvSpPr>
-        <p:spPr/>
-        <p:txBody>
-          <a:bodyPr/>
-          <a:lstStyle/>
-          <a:p>
-            <a:endParaRPr lang="en-US"/>
+              <a:t>Modeling mindsets:</a:t>
+            </a:r>
+          </a:p>
+        </p:txBody>
+      </p:sp>
+      <p:sp>
+        <p:nvSpPr>
+          <p:cNvPr id="5" name="TextBox 4">
+            <a:extLst>
+              <a:ext uri="{FF2B5EF4-FFF2-40B4-BE49-F238E27FC236}">
+                <a16:creationId xmlns:a16="http://schemas.microsoft.com/office/drawing/2014/main" id="{BEBAE4EA-CF84-8D15-A012-827FA43EBAE9}"/>
+              </a:ext>
+            </a:extLst>
+          </p:cNvPr>
+          <p:cNvSpPr txBox="1"/>
+          <p:nvPr/>
+        </p:nvSpPr>
+        <p:spPr>
+          <a:xfrm>
+            <a:off x="4537276" y="6488668"/>
+            <a:ext cx="8191983" cy="369332"/>
+          </a:xfrm>
+          <a:prstGeom prst="rect">
+            <a:avLst/>
+          </a:prstGeom>
+          <a:noFill/>
+        </p:spPr>
+        <p:txBody>
+          <a:bodyPr wrap="square">
+            <a:spAutoFit/>
+          </a:bodyPr>
+          <a:lstStyle/>
+          <a:p>
+            <a:r>
+              <a:rPr lang="en-US" dirty="0">
+                <a:hlinkClick r:id="rId3"/>
+              </a:rPr>
+              <a:t>Molnar, C. 2023. Modeling mindsets: the many cultures of learning from data.</a:t>
+            </a:r>
+            <a:endParaRPr lang="en-US" dirty="0"/>
+          </a:p>
+        </p:txBody>
+      </p:sp>
+      <p:pic>
+        <p:nvPicPr>
+          <p:cNvPr id="4" name="Picture 3">
+            <a:extLst>
+              <a:ext uri="{FF2B5EF4-FFF2-40B4-BE49-F238E27FC236}">
+                <a16:creationId xmlns:a16="http://schemas.microsoft.com/office/drawing/2014/main" id="{842C5C56-775E-EEF7-CB65-D043B00C9B5E}"/>
+              </a:ext>
+            </a:extLst>
+          </p:cNvPr>
+          <p:cNvPicPr>
+            <a:picLocks noChangeAspect="1"/>
+          </p:cNvPicPr>
+          <p:nvPr/>
+        </p:nvPicPr>
+        <p:blipFill>
+          <a:blip r:embed="rId4"/>
+          <a:stretch>
+            <a:fillRect/>
+          </a:stretch>
+        </p:blipFill>
+        <p:spPr>
+          <a:xfrm>
+            <a:off x="2209800" y="1806291"/>
+            <a:ext cx="7772400" cy="4326071"/>
+          </a:xfrm>
+          <a:prstGeom prst="rect">
+            <a:avLst/>
+          </a:prstGeom>
+        </p:spPr>
+      </p:pic>
+      <p:sp>
+        <p:nvSpPr>
+          <p:cNvPr id="7" name="TextBox 6">
+            <a:extLst>
+              <a:ext uri="{FF2B5EF4-FFF2-40B4-BE49-F238E27FC236}">
+                <a16:creationId xmlns:a16="http://schemas.microsoft.com/office/drawing/2014/main" id="{F8E62159-9C2F-27F9-3386-557A8560833C}"/>
+              </a:ext>
+            </a:extLst>
+          </p:cNvPr>
+          <p:cNvSpPr txBox="1"/>
+          <p:nvPr/>
+        </p:nvSpPr>
+        <p:spPr>
+          <a:xfrm>
+            <a:off x="260933" y="1690688"/>
+            <a:ext cx="3897734" cy="646331"/>
+          </a:xfrm>
+          <a:prstGeom prst="rect">
+            <a:avLst/>
+          </a:prstGeom>
+          <a:noFill/>
+        </p:spPr>
+        <p:txBody>
+          <a:bodyPr wrap="none" rtlCol="0">
+            <a:spAutoFit/>
+          </a:bodyPr>
+          <a:lstStyle/>
+          <a:p>
+            <a:r>
+              <a:rPr lang="en-US" dirty="0">
+                <a:solidFill>
+                  <a:schemeClr val="accent2"/>
+                </a:solidFill>
+              </a:rPr>
+              <a:t>Everything is a probability distribution</a:t>
+            </a:r>
+          </a:p>
+          <a:p>
+            <a:r>
+              <a:rPr lang="en-US" dirty="0">
+                <a:solidFill>
+                  <a:schemeClr val="accent2"/>
+                </a:solidFill>
+              </a:rPr>
+              <a:t>Models = hypotheses</a:t>
+            </a:r>
+          </a:p>
+        </p:txBody>
+      </p:sp>
+      <p:sp>
+        <p:nvSpPr>
+          <p:cNvPr id="8" name="TextBox 7">
+            <a:extLst>
+              <a:ext uri="{FF2B5EF4-FFF2-40B4-BE49-F238E27FC236}">
+                <a16:creationId xmlns:a16="http://schemas.microsoft.com/office/drawing/2014/main" id="{6938CC4B-4A98-2DAA-33B5-974641709A35}"/>
+              </a:ext>
+            </a:extLst>
+          </p:cNvPr>
+          <p:cNvSpPr txBox="1"/>
+          <p:nvPr/>
+        </p:nvSpPr>
+        <p:spPr>
+          <a:xfrm>
+            <a:off x="7990468" y="1314843"/>
+            <a:ext cx="3787832" cy="646331"/>
+          </a:xfrm>
+          <a:prstGeom prst="rect">
+            <a:avLst/>
+          </a:prstGeom>
+          <a:noFill/>
+        </p:spPr>
+        <p:txBody>
+          <a:bodyPr wrap="none" rtlCol="0">
+            <a:spAutoFit/>
+          </a:bodyPr>
+          <a:lstStyle/>
+          <a:p>
+            <a:r>
+              <a:rPr lang="en-US" dirty="0">
+                <a:solidFill>
+                  <a:schemeClr val="accent2"/>
+                </a:solidFill>
+              </a:rPr>
+              <a:t>Models = algorithms that solve tasks</a:t>
+            </a:r>
+          </a:p>
+          <a:p>
+            <a:r>
+              <a:rPr lang="en-US" dirty="0">
+                <a:solidFill>
+                  <a:schemeClr val="accent2"/>
+                </a:solidFill>
+              </a:rPr>
+              <a:t>Prediction-focused</a:t>
+            </a:r>
           </a:p>
         </p:txBody>
       </p:sp>
     </p:spTree>
     <p:extLst>
       <p:ext uri="{BB962C8B-B14F-4D97-AF65-F5344CB8AC3E}">
-        <p14:creationId xmlns:p14="http://schemas.microsoft.com/office/powerpoint/2010/main" val="3618598819"/>
+        <p14:creationId xmlns:p14="http://schemas.microsoft.com/office/powerpoint/2010/main" val="4070516429"/>
       </p:ext>
     </p:extLst>
   </p:cSld>
@@ -4265,7 +4775,13 @@
   <p:cSld>
     <p:spTree>
       <p:nvGrpSpPr>
-        <p:cNvPr id="1" name=""/>
+        <p:cNvPr id="1" name="">
+          <a:extLst>
+            <a:ext uri="{FF2B5EF4-FFF2-40B4-BE49-F238E27FC236}">
+              <a16:creationId xmlns:a16="http://schemas.microsoft.com/office/drawing/2014/main" id="{35C5AACF-183C-4CE6-7C9C-CC4AD7841DCD}"/>
+            </a:ext>
+          </a:extLst>
+        </p:cNvPr>
         <p:cNvGrpSpPr/>
         <p:nvPr/>
       </p:nvGrpSpPr>
@@ -4282,7 +4798,7 @@
           <p:cNvPr id="2" name="Title 1">
             <a:extLst>
               <a:ext uri="{FF2B5EF4-FFF2-40B4-BE49-F238E27FC236}">
-                <a16:creationId xmlns:a16="http://schemas.microsoft.com/office/drawing/2014/main" id="{12EAFA29-EE37-3E25-4512-716D446C9A08}"/>
+                <a16:creationId xmlns:a16="http://schemas.microsoft.com/office/drawing/2014/main" id="{23D67ECA-8789-A647-2D9B-2A521FBC218C}"/>
               </a:ext>
             </a:extLst>
           </p:cNvPr>
@@ -4300,43 +4816,238 @@
           <a:p>
             <a:r>
               <a:rPr lang="en-US" dirty="0"/>
-              <a:t>In science, we often have multiple aims</a:t>
-            </a:r>
-          </a:p>
-        </p:txBody>
-      </p:sp>
-      <p:sp>
-        <p:nvSpPr>
-          <p:cNvPr id="3" name="Content Placeholder 2">
-            <a:extLst>
-              <a:ext uri="{FF2B5EF4-FFF2-40B4-BE49-F238E27FC236}">
-                <a16:creationId xmlns:a16="http://schemas.microsoft.com/office/drawing/2014/main" id="{1C8C50EC-2B77-57DB-6553-55037FAA5831}"/>
-              </a:ext>
-            </a:extLst>
-          </p:cNvPr>
-          <p:cNvSpPr>
-            <a:spLocks noGrp="1"/>
-          </p:cNvSpPr>
-          <p:nvPr>
-            <p:ph idx="1"/>
-          </p:nvPr>
-        </p:nvSpPr>
-        <p:spPr/>
-        <p:txBody>
-          <a:bodyPr/>
-          <a:lstStyle/>
-          <a:p>
-            <a:r>
-              <a:rPr lang="en-US" dirty="0"/>
-              <a:t>INSERT how the mindsets overlap, especially how ML isn’t just prediction (anymore)</a:t>
-            </a:r>
+              <a:t>Modeling mindsets:</a:t>
+            </a:r>
+          </a:p>
+        </p:txBody>
+      </p:sp>
+      <p:sp>
+        <p:nvSpPr>
+          <p:cNvPr id="5" name="TextBox 4">
+            <a:extLst>
+              <a:ext uri="{FF2B5EF4-FFF2-40B4-BE49-F238E27FC236}">
+                <a16:creationId xmlns:a16="http://schemas.microsoft.com/office/drawing/2014/main" id="{1780C0F4-C8CA-C965-A598-993797958E6A}"/>
+              </a:ext>
+            </a:extLst>
+          </p:cNvPr>
+          <p:cNvSpPr txBox="1"/>
+          <p:nvPr/>
+        </p:nvSpPr>
+        <p:spPr>
+          <a:xfrm>
+            <a:off x="4537276" y="6488668"/>
+            <a:ext cx="8191983" cy="369332"/>
+          </a:xfrm>
+          <a:prstGeom prst="rect">
+            <a:avLst/>
+          </a:prstGeom>
+          <a:noFill/>
+        </p:spPr>
+        <p:txBody>
+          <a:bodyPr wrap="square">
+            <a:spAutoFit/>
+          </a:bodyPr>
+          <a:lstStyle/>
+          <a:p>
+            <a:r>
+              <a:rPr lang="en-US" dirty="0">
+                <a:hlinkClick r:id="rId3"/>
+              </a:rPr>
+              <a:t>Molnar, C. 2023. Modeling mindsets: the many cultures of learning from data.</a:t>
+            </a:r>
+            <a:endParaRPr lang="en-US" dirty="0"/>
+          </a:p>
+        </p:txBody>
+      </p:sp>
+      <p:pic>
+        <p:nvPicPr>
+          <p:cNvPr id="4" name="Picture 3">
+            <a:extLst>
+              <a:ext uri="{FF2B5EF4-FFF2-40B4-BE49-F238E27FC236}">
+                <a16:creationId xmlns:a16="http://schemas.microsoft.com/office/drawing/2014/main" id="{08C6B90A-F609-9895-9F14-FBB0004B007E}"/>
+              </a:ext>
+            </a:extLst>
+          </p:cNvPr>
+          <p:cNvPicPr>
+            <a:picLocks noChangeAspect="1"/>
+          </p:cNvPicPr>
+          <p:nvPr/>
+        </p:nvPicPr>
+        <p:blipFill>
+          <a:blip r:embed="rId4"/>
+          <a:stretch>
+            <a:fillRect/>
+          </a:stretch>
+        </p:blipFill>
+        <p:spPr>
+          <a:xfrm>
+            <a:off x="2209800" y="1806291"/>
+            <a:ext cx="7772400" cy="4326071"/>
+          </a:xfrm>
+          <a:prstGeom prst="rect">
+            <a:avLst/>
+          </a:prstGeom>
+        </p:spPr>
+      </p:pic>
+      <p:sp>
+        <p:nvSpPr>
+          <p:cNvPr id="7" name="TextBox 6">
+            <a:extLst>
+              <a:ext uri="{FF2B5EF4-FFF2-40B4-BE49-F238E27FC236}">
+                <a16:creationId xmlns:a16="http://schemas.microsoft.com/office/drawing/2014/main" id="{1631F4C1-10A5-2ED7-FF28-F9C2637215CE}"/>
+              </a:ext>
+            </a:extLst>
+          </p:cNvPr>
+          <p:cNvSpPr txBox="1"/>
+          <p:nvPr/>
+        </p:nvSpPr>
+        <p:spPr>
+          <a:xfrm>
+            <a:off x="260933" y="1690688"/>
+            <a:ext cx="3897734" cy="646331"/>
+          </a:xfrm>
+          <a:prstGeom prst="rect">
+            <a:avLst/>
+          </a:prstGeom>
+          <a:noFill/>
+        </p:spPr>
+        <p:txBody>
+          <a:bodyPr wrap="none" rtlCol="0">
+            <a:spAutoFit/>
+          </a:bodyPr>
+          <a:lstStyle/>
+          <a:p>
+            <a:r>
+              <a:rPr lang="en-US" dirty="0">
+                <a:solidFill>
+                  <a:schemeClr val="accent2"/>
+                </a:solidFill>
+              </a:rPr>
+              <a:t>Everything is a probability distribution</a:t>
+            </a:r>
+          </a:p>
+          <a:p>
+            <a:r>
+              <a:rPr lang="en-US" dirty="0">
+                <a:solidFill>
+                  <a:schemeClr val="accent2"/>
+                </a:solidFill>
+              </a:rPr>
+              <a:t>Models = hypotheses</a:t>
+            </a:r>
+          </a:p>
+        </p:txBody>
+      </p:sp>
+      <p:sp>
+        <p:nvSpPr>
+          <p:cNvPr id="8" name="TextBox 7">
+            <a:extLst>
+              <a:ext uri="{FF2B5EF4-FFF2-40B4-BE49-F238E27FC236}">
+                <a16:creationId xmlns:a16="http://schemas.microsoft.com/office/drawing/2014/main" id="{D99F50EB-19FD-33C3-848A-2D1B9B2C4576}"/>
+              </a:ext>
+            </a:extLst>
+          </p:cNvPr>
+          <p:cNvSpPr txBox="1"/>
+          <p:nvPr/>
+        </p:nvSpPr>
+        <p:spPr>
+          <a:xfrm>
+            <a:off x="7990468" y="1314843"/>
+            <a:ext cx="3787832" cy="646331"/>
+          </a:xfrm>
+          <a:prstGeom prst="rect">
+            <a:avLst/>
+          </a:prstGeom>
+          <a:noFill/>
+        </p:spPr>
+        <p:txBody>
+          <a:bodyPr wrap="none" rtlCol="0">
+            <a:spAutoFit/>
+          </a:bodyPr>
+          <a:lstStyle/>
+          <a:p>
+            <a:r>
+              <a:rPr lang="en-US" dirty="0">
+                <a:solidFill>
+                  <a:schemeClr val="accent2"/>
+                </a:solidFill>
+              </a:rPr>
+              <a:t>Models = algorithms that solve tasks</a:t>
+            </a:r>
+          </a:p>
+          <a:p>
+            <a:r>
+              <a:rPr lang="en-US" dirty="0">
+                <a:solidFill>
+                  <a:schemeClr val="accent2"/>
+                </a:solidFill>
+              </a:rPr>
+              <a:t>Prediction-focused</a:t>
+            </a:r>
+          </a:p>
+        </p:txBody>
+      </p:sp>
+      <p:sp>
+        <p:nvSpPr>
+          <p:cNvPr id="3" name="L-Shape 2">
+            <a:extLst>
+              <a:ext uri="{FF2B5EF4-FFF2-40B4-BE49-F238E27FC236}">
+                <a16:creationId xmlns:a16="http://schemas.microsoft.com/office/drawing/2014/main" id="{E4CACA2F-C7C4-9B88-0F05-61329F8C8FDA}"/>
+              </a:ext>
+            </a:extLst>
+          </p:cNvPr>
+          <p:cNvSpPr/>
+          <p:nvPr/>
+        </p:nvSpPr>
+        <p:spPr>
+          <a:xfrm rot="16200000">
+            <a:off x="6776567" y="2297985"/>
+            <a:ext cx="2714124" cy="3697147"/>
+          </a:xfrm>
+          <a:prstGeom prst="corner">
+            <a:avLst>
+              <a:gd name="adj1" fmla="val 73167"/>
+              <a:gd name="adj2" fmla="val 54564"/>
+            </a:avLst>
+          </a:prstGeom>
+          <a:solidFill>
+            <a:srgbClr val="FFFFFF">
+              <a:alpha val="80000"/>
+            </a:srgbClr>
+          </a:solidFill>
+          <a:ln>
+            <a:noFill/>
+          </a:ln>
+        </p:spPr>
+        <p:style>
+          <a:lnRef idx="2">
+            <a:schemeClr val="accent1">
+              <a:shade val="15000"/>
+            </a:schemeClr>
+          </a:lnRef>
+          <a:fillRef idx="1">
+            <a:schemeClr val="accent1"/>
+          </a:fillRef>
+          <a:effectRef idx="0">
+            <a:schemeClr val="accent1"/>
+          </a:effectRef>
+          <a:fontRef idx="minor">
+            <a:schemeClr val="lt1"/>
+          </a:fontRef>
+        </p:style>
+        <p:txBody>
+          <a:bodyPr rtlCol="0" anchor="ctr"/>
+          <a:lstStyle/>
+          <a:p>
+            <a:pPr algn="ctr"/>
+            <a:endParaRPr lang="en-US"/>
           </a:p>
         </p:txBody>
       </p:sp>
     </p:spTree>
     <p:extLst>
       <p:ext uri="{BB962C8B-B14F-4D97-AF65-F5344CB8AC3E}">
-        <p14:creationId xmlns:p14="http://schemas.microsoft.com/office/powerpoint/2010/main" val="1836443162"/>
+        <p14:creationId xmlns:p14="http://schemas.microsoft.com/office/powerpoint/2010/main" val="537992282"/>
       </p:ext>
     </p:extLst>
   </p:cSld>
@@ -4368,7 +5079,7 @@
           <p:cNvPr id="2" name="Title 1">
             <a:extLst>
               <a:ext uri="{FF2B5EF4-FFF2-40B4-BE49-F238E27FC236}">
-                <a16:creationId xmlns:a16="http://schemas.microsoft.com/office/drawing/2014/main" id="{C9B32982-8ECF-843F-BE49-2E046B46EC43}"/>
+                <a16:creationId xmlns:a16="http://schemas.microsoft.com/office/drawing/2014/main" id="{39A625AB-F6E4-98FC-D933-D387F1C7A211}"/>
               </a:ext>
             </a:extLst>
           </p:cNvPr>
@@ -4386,7 +5097,7 @@
           <a:p>
             <a:r>
               <a:rPr lang="en-US" dirty="0"/>
-              <a:t>Why prediction matters for science, and especially environmental science</a:t>
+              <a:t>The same “model” can fit into multiple mindsets</a:t>
             </a:r>
           </a:p>
         </p:txBody>
@@ -4396,7 +5107,7 @@
           <p:cNvPr id="3" name="Content Placeholder 2">
             <a:extLst>
               <a:ext uri="{FF2B5EF4-FFF2-40B4-BE49-F238E27FC236}">
-                <a16:creationId xmlns:a16="http://schemas.microsoft.com/office/drawing/2014/main" id="{EFC01B0B-71D1-BCA4-5138-21A233C4CFFA}"/>
+                <a16:creationId xmlns:a16="http://schemas.microsoft.com/office/drawing/2014/main" id="{8B1AFB84-49E9-1766-E894-C057538D6BC6}"/>
               </a:ext>
             </a:extLst>
           </p:cNvPr>
@@ -4407,19 +5118,77 @@
             <p:ph idx="1"/>
           </p:nvPr>
         </p:nvSpPr>
-        <p:spPr/>
-        <p:txBody>
-          <a:bodyPr/>
-          <a:lstStyle/>
-          <a:p>
-            <a:endParaRPr lang="en-US"/>
-          </a:p>
-        </p:txBody>
-      </p:sp>
+        <p:spPr>
+          <a:xfrm>
+            <a:off x="838200" y="1825625"/>
+            <a:ext cx="5539451" cy="4351338"/>
+          </a:xfrm>
+        </p:spPr>
+        <p:txBody>
+          <a:bodyPr>
+            <a:normAutofit lnSpcReduction="10000"/>
+          </a:bodyPr>
+          <a:lstStyle/>
+          <a:p>
+            <a:r>
+              <a:rPr lang="en-US" dirty="0"/>
+              <a:t>A frequentist can use a linear regression to test a hypothesis</a:t>
+            </a:r>
+          </a:p>
+          <a:p>
+            <a:endParaRPr lang="en-US" dirty="0"/>
+          </a:p>
+          <a:p>
+            <a:r>
+              <a:rPr lang="en-US" dirty="0"/>
+              <a:t>A Bayesian can measure the posterior distribution of a linear coefficient</a:t>
+            </a:r>
+          </a:p>
+          <a:p>
+            <a:endParaRPr lang="en-US" dirty="0"/>
+          </a:p>
+          <a:p>
+            <a:r>
+              <a:rPr lang="en-US" dirty="0"/>
+              <a:t>A machine learner can use a linear regression to predict unobserved data</a:t>
+            </a:r>
+          </a:p>
+        </p:txBody>
+      </p:sp>
+      <p:pic>
+        <p:nvPicPr>
+          <p:cNvPr id="4" name="Picture 3">
+            <a:extLst>
+              <a:ext uri="{FF2B5EF4-FFF2-40B4-BE49-F238E27FC236}">
+                <a16:creationId xmlns:a16="http://schemas.microsoft.com/office/drawing/2014/main" id="{E871CE6A-172E-F53A-D1BB-B794941166C8}"/>
+              </a:ext>
+            </a:extLst>
+          </p:cNvPr>
+          <p:cNvPicPr>
+            <a:picLocks noChangeAspect="1"/>
+          </p:cNvPicPr>
+          <p:nvPr/>
+        </p:nvPicPr>
+        <p:blipFill>
+          <a:blip r:embed="rId2"/>
+          <a:stretch>
+            <a:fillRect/>
+          </a:stretch>
+        </p:blipFill>
+        <p:spPr>
+          <a:xfrm>
+            <a:off x="6866082" y="1825625"/>
+            <a:ext cx="3835400" cy="3721100"/>
+          </a:xfrm>
+          <a:prstGeom prst="rect">
+            <a:avLst/>
+          </a:prstGeom>
+        </p:spPr>
+      </p:pic>
     </p:spTree>
     <p:extLst>
       <p:ext uri="{BB962C8B-B14F-4D97-AF65-F5344CB8AC3E}">
-        <p14:creationId xmlns:p14="http://schemas.microsoft.com/office/powerpoint/2010/main" val="2164193552"/>
+        <p14:creationId xmlns:p14="http://schemas.microsoft.com/office/powerpoint/2010/main" val="3411858404"/>
       </p:ext>
     </p:extLst>
   </p:cSld>
@@ -4451,7 +5220,7 @@
           <p:cNvPr id="2" name="Title 1">
             <a:extLst>
               <a:ext uri="{FF2B5EF4-FFF2-40B4-BE49-F238E27FC236}">
-                <a16:creationId xmlns:a16="http://schemas.microsoft.com/office/drawing/2014/main" id="{2ED9C620-C9E2-7961-B5F8-4FE45A9746AC}"/>
+                <a16:creationId xmlns:a16="http://schemas.microsoft.com/office/drawing/2014/main" id="{12EAFA29-EE37-3E25-4512-716D446C9A08}"/>
               </a:ext>
             </a:extLst>
           </p:cNvPr>
@@ -4469,11 +5238,7 @@
           <a:p>
             <a:r>
               <a:rPr lang="en-US" dirty="0"/>
-              <a:t>Here, we’ll focus on </a:t>
-            </a:r>
-            <a:r>
-              <a:rPr lang="en-US" b="1" dirty="0"/>
-              <a:t>supervised machine learning</a:t>
+              <a:t>In science, we often have multiple aims</a:t>
             </a:r>
           </a:p>
         </p:txBody>
@@ -4483,7 +5248,7 @@
           <p:cNvPr id="3" name="Content Placeholder 2">
             <a:extLst>
               <a:ext uri="{FF2B5EF4-FFF2-40B4-BE49-F238E27FC236}">
-                <a16:creationId xmlns:a16="http://schemas.microsoft.com/office/drawing/2014/main" id="{2CE455A1-1296-7EDE-EF6F-761FAC88DD18}"/>
+                <a16:creationId xmlns:a16="http://schemas.microsoft.com/office/drawing/2014/main" id="{1C8C50EC-2B77-57DB-6553-55037FAA5831}"/>
               </a:ext>
             </a:extLst>
           </p:cNvPr>
@@ -4501,13 +5266,7 @@
           <a:p>
             <a:r>
               <a:rPr lang="en-US" dirty="0"/>
-              <a:t>Point to other techniques and their uses</a:t>
-            </a:r>
-          </a:p>
-          <a:p>
-            <a:r>
-              <a:rPr lang="en-US" dirty="0"/>
-              <a:t>Highlight supervised ML methods and their advantages</a:t>
+              <a:t>INSERT how the mindsets overlap, especially how ML isn’t just prediction (anymore)</a:t>
             </a:r>
           </a:p>
         </p:txBody>
@@ -4515,7 +5274,7 @@
     </p:spTree>
     <p:extLst>
       <p:ext uri="{BB962C8B-B14F-4D97-AF65-F5344CB8AC3E}">
-        <p14:creationId xmlns:p14="http://schemas.microsoft.com/office/powerpoint/2010/main" val="1190854385"/>
+        <p14:creationId xmlns:p14="http://schemas.microsoft.com/office/powerpoint/2010/main" val="1836443162"/>
       </p:ext>
     </p:extLst>
   </p:cSld>
@@ -4547,7 +5306,7 @@
           <p:cNvPr id="2" name="Title 1">
             <a:extLst>
               <a:ext uri="{FF2B5EF4-FFF2-40B4-BE49-F238E27FC236}">
-                <a16:creationId xmlns:a16="http://schemas.microsoft.com/office/drawing/2014/main" id="{153415BC-5788-8EC6-12AC-481C31DFB6A3}"/>
+                <a16:creationId xmlns:a16="http://schemas.microsoft.com/office/drawing/2014/main" id="{C9B32982-8ECF-843F-BE49-2E046B46EC43}"/>
               </a:ext>
             </a:extLst>
           </p:cNvPr>
@@ -4565,7 +5324,7 @@
           <a:p>
             <a:r>
               <a:rPr lang="en-US" dirty="0"/>
-              <a:t>Overview of the day</a:t>
+              <a:t>Why prediction matters for science, and especially environmental science</a:t>
             </a:r>
           </a:p>
         </p:txBody>
@@ -4575,7 +5334,7 @@
           <p:cNvPr id="3" name="Content Placeholder 2">
             <a:extLst>
               <a:ext uri="{FF2B5EF4-FFF2-40B4-BE49-F238E27FC236}">
-                <a16:creationId xmlns:a16="http://schemas.microsoft.com/office/drawing/2014/main" id="{907FD6AA-9804-3A4F-934C-265DF31BAADB}"/>
+                <a16:creationId xmlns:a16="http://schemas.microsoft.com/office/drawing/2014/main" id="{EFC01B0B-71D1-BCA4-5138-21A233C4CFFA}"/>
               </a:ext>
             </a:extLst>
           </p:cNvPr>
@@ -4598,7 +5357,7 @@
     </p:spTree>
     <p:extLst>
       <p:ext uri="{BB962C8B-B14F-4D97-AF65-F5344CB8AC3E}">
-        <p14:creationId xmlns:p14="http://schemas.microsoft.com/office/powerpoint/2010/main" val="2376821870"/>
+        <p14:creationId xmlns:p14="http://schemas.microsoft.com/office/powerpoint/2010/main" val="2164193552"/>
       </p:ext>
     </p:extLst>
   </p:cSld>
@@ -4630,7 +5389,7 @@
           <p:cNvPr id="2" name="Title 1">
             <a:extLst>
               <a:ext uri="{FF2B5EF4-FFF2-40B4-BE49-F238E27FC236}">
-                <a16:creationId xmlns:a16="http://schemas.microsoft.com/office/drawing/2014/main" id="{8F4609B2-8DAD-0237-B6AF-7CC64EAB54FC}"/>
+                <a16:creationId xmlns:a16="http://schemas.microsoft.com/office/drawing/2014/main" id="{2ED9C620-C9E2-7961-B5F8-4FE45A9746AC}"/>
               </a:ext>
             </a:extLst>
           </p:cNvPr>
@@ -4648,7 +5407,11 @@
           <a:p>
             <a:r>
               <a:rPr lang="en-US" dirty="0"/>
-              <a:t>Break out groups (~5min)</a:t>
+              <a:t>Here, we’ll focus on </a:t>
+            </a:r>
+            <a:r>
+              <a:rPr lang="en-US" b="1" dirty="0"/>
+              <a:t>supervised machine learning</a:t>
             </a:r>
           </a:p>
         </p:txBody>
@@ -4658,7 +5421,7 @@
           <p:cNvPr id="3" name="Content Placeholder 2">
             <a:extLst>
               <a:ext uri="{FF2B5EF4-FFF2-40B4-BE49-F238E27FC236}">
-                <a16:creationId xmlns:a16="http://schemas.microsoft.com/office/drawing/2014/main" id="{29D0A7A8-6062-EB24-E8E3-40035D8AB20C}"/>
+                <a16:creationId xmlns:a16="http://schemas.microsoft.com/office/drawing/2014/main" id="{2CE455A1-1296-7EDE-EF6F-761FAC88DD18}"/>
               </a:ext>
             </a:extLst>
           </p:cNvPr>
@@ -4674,36 +5437,15 @@
           <a:bodyPr/>
           <a:lstStyle/>
           <a:p>
-            <a:pPr marL="0" indent="0">
-              <a:buNone/>
-            </a:pPr>
             <a:r>
               <a:rPr lang="en-US" dirty="0"/>
-              <a:t>Talk with folks at your table:</a:t>
+              <a:t>Point to other techniques and their uses</a:t>
             </a:r>
           </a:p>
           <a:p>
             <a:r>
               <a:rPr lang="en-US" dirty="0"/>
-              <a:t>Names</a:t>
-            </a:r>
-          </a:p>
-          <a:p>
-            <a:r>
-              <a:rPr lang="en-US" dirty="0"/>
-              <a:t>What modeling mindset(s) you typically use in your work</a:t>
-            </a:r>
-          </a:p>
-          <a:p>
-            <a:r>
-              <a:rPr lang="en-US" dirty="0"/>
-              <a:t>What interests brought you to this workshop today</a:t>
-            </a:r>
-          </a:p>
-          <a:p>
-            <a:r>
-              <a:rPr lang="en-US" dirty="0"/>
-              <a:t>Favorite body of water (anywhere, any type)</a:t>
+              <a:t>Highlight supervised ML methods and their advantages</a:t>
             </a:r>
           </a:p>
         </p:txBody>
@@ -4711,7 +5453,90 @@
     </p:spTree>
     <p:extLst>
       <p:ext uri="{BB962C8B-B14F-4D97-AF65-F5344CB8AC3E}">
-        <p14:creationId xmlns:p14="http://schemas.microsoft.com/office/powerpoint/2010/main" val="3850885334"/>
+        <p14:creationId xmlns:p14="http://schemas.microsoft.com/office/powerpoint/2010/main" val="1190854385"/>
+      </p:ext>
+    </p:extLst>
+  </p:cSld>
+  <p:clrMapOvr>
+    <a:masterClrMapping/>
+  </p:clrMapOvr>
+</p:sld>
+</file>
+
+<file path=ppt/slides/slide9.xml><?xml version="1.0" encoding="utf-8"?>
+<p:sld xmlns:a="http://schemas.openxmlformats.org/drawingml/2006/main" xmlns:r="http://schemas.openxmlformats.org/officeDocument/2006/relationships" xmlns:p="http://schemas.openxmlformats.org/presentationml/2006/main">
+  <p:cSld>
+    <p:spTree>
+      <p:nvGrpSpPr>
+        <p:cNvPr id="1" name=""/>
+        <p:cNvGrpSpPr/>
+        <p:nvPr/>
+      </p:nvGrpSpPr>
+      <p:grpSpPr>
+        <a:xfrm>
+          <a:off x="0" y="0"/>
+          <a:ext cx="0" cy="0"/>
+          <a:chOff x="0" y="0"/>
+          <a:chExt cx="0" cy="0"/>
+        </a:xfrm>
+      </p:grpSpPr>
+      <p:sp>
+        <p:nvSpPr>
+          <p:cNvPr id="2" name="Title 1">
+            <a:extLst>
+              <a:ext uri="{FF2B5EF4-FFF2-40B4-BE49-F238E27FC236}">
+                <a16:creationId xmlns:a16="http://schemas.microsoft.com/office/drawing/2014/main" id="{153415BC-5788-8EC6-12AC-481C31DFB6A3}"/>
+              </a:ext>
+            </a:extLst>
+          </p:cNvPr>
+          <p:cNvSpPr>
+            <a:spLocks noGrp="1"/>
+          </p:cNvSpPr>
+          <p:nvPr>
+            <p:ph type="title"/>
+          </p:nvPr>
+        </p:nvSpPr>
+        <p:spPr/>
+        <p:txBody>
+          <a:bodyPr/>
+          <a:lstStyle/>
+          <a:p>
+            <a:r>
+              <a:rPr lang="en-US" dirty="0"/>
+              <a:t>Overview of the day</a:t>
+            </a:r>
+          </a:p>
+        </p:txBody>
+      </p:sp>
+      <p:sp>
+        <p:nvSpPr>
+          <p:cNvPr id="3" name="Content Placeholder 2">
+            <a:extLst>
+              <a:ext uri="{FF2B5EF4-FFF2-40B4-BE49-F238E27FC236}">
+                <a16:creationId xmlns:a16="http://schemas.microsoft.com/office/drawing/2014/main" id="{907FD6AA-9804-3A4F-934C-265DF31BAADB}"/>
+              </a:ext>
+            </a:extLst>
+          </p:cNvPr>
+          <p:cNvSpPr>
+            <a:spLocks noGrp="1"/>
+          </p:cNvSpPr>
+          <p:nvPr>
+            <p:ph idx="1"/>
+          </p:nvPr>
+        </p:nvSpPr>
+        <p:spPr/>
+        <p:txBody>
+          <a:bodyPr/>
+          <a:lstStyle/>
+          <a:p>
+            <a:endParaRPr lang="en-US"/>
+          </a:p>
+        </p:txBody>
+      </p:sp>
+    </p:spTree>
+    <p:extLst>
+      <p:ext uri="{BB962C8B-B14F-4D97-AF65-F5344CB8AC3E}">
+        <p14:creationId xmlns:p14="http://schemas.microsoft.com/office/powerpoint/2010/main" val="2376821870"/>
       </p:ext>
     </p:extLst>
   </p:cSld>

</xml_diff>

<commit_message>
lccmr logo on slides
</commit_message>
<xml_diff>
--- a/slides/01_what_is_ml.pptx
+++ b/slides/01_what_is_ml.pptx
@@ -531,7 +531,15 @@
           <a:p>
             <a:r>
               <a:rPr lang="en-US" dirty="0"/>
-              <a:t>Restroom locations, food/coffee locations, water location, people to ask questions, outlets/cords.</a:t>
+              <a:t>Intros for </a:t>
+            </a:r>
+            <a:r>
+              <a:rPr lang="en-US"/>
+              <a:t>facilitators, restroom </a:t>
+            </a:r>
+            <a:r>
+              <a:rPr lang="en-US" dirty="0"/>
+              <a:t>locations, food/coffee locations, water location, people to ask questions, outlets/cords.</a:t>
             </a:r>
           </a:p>
         </p:txBody>
@@ -5692,6 +5700,53 @@
           </a:p>
         </p:txBody>
       </p:sp>
+      <p:pic>
+        <p:nvPicPr>
+          <p:cNvPr id="1026" name="Picture 2">
+            <a:extLst>
+              <a:ext uri="{FF2B5EF4-FFF2-40B4-BE49-F238E27FC236}">
+                <a16:creationId xmlns:a16="http://schemas.microsoft.com/office/drawing/2014/main" id="{B6A382C2-F87D-0EF6-3E73-2AA660B16486}"/>
+              </a:ext>
+            </a:extLst>
+          </p:cNvPr>
+          <p:cNvPicPr>
+            <a:picLocks noChangeAspect="1" noChangeArrowheads="1"/>
+          </p:cNvPicPr>
+          <p:nvPr/>
+        </p:nvPicPr>
+        <p:blipFill>
+          <a:blip r:embed="rId3">
+            <a:extLst>
+              <a:ext uri="{28A0092B-C50C-407E-A947-70E740481C1C}">
+                <a14:useLocalDpi xmlns:a14="http://schemas.microsoft.com/office/drawing/2010/main" val="0"/>
+              </a:ext>
+            </a:extLst>
+          </a:blip>
+          <a:srcRect/>
+          <a:stretch>
+            <a:fillRect/>
+          </a:stretch>
+        </p:blipFill>
+        <p:spPr bwMode="auto">
+          <a:xfrm>
+            <a:off x="10103358" y="5256498"/>
+            <a:ext cx="2070984" cy="1465703"/>
+          </a:xfrm>
+          <a:prstGeom prst="rect">
+            <a:avLst/>
+          </a:prstGeom>
+          <a:noFill/>
+          <a:extLst>
+            <a:ext uri="{909E8E84-426E-40DD-AFC4-6F175D3DCCD1}">
+              <a14:hiddenFill xmlns:a14="http://schemas.microsoft.com/office/drawing/2010/main">
+                <a:solidFill>
+                  <a:srgbClr val="FFFFFF"/>
+                </a:solidFill>
+              </a14:hiddenFill>
+            </a:ext>
+          </a:extLst>
+        </p:spPr>
+      </p:pic>
     </p:spTree>
     <p:extLst>
       <p:ext uri="{BB962C8B-B14F-4D97-AF65-F5344CB8AC3E}">

</xml_diff>

<commit_message>
updated slides after run through
</commit_message>
<xml_diff>
--- a/slides/01_what_is_ml.pptx
+++ b/slides/01_what_is_ml.pptx
@@ -5,31 +5,32 @@
     <p:sldMasterId id="2147483648" r:id="rId1"/>
   </p:sldMasterIdLst>
   <p:notesMasterIdLst>
-    <p:notesMasterId r:id="rId24"/>
+    <p:notesMasterId r:id="rId25"/>
   </p:notesMasterIdLst>
   <p:sldIdLst>
     <p:sldId id="262" r:id="rId2"/>
-    <p:sldId id="256" r:id="rId3"/>
-    <p:sldId id="257" r:id="rId4"/>
-    <p:sldId id="266" r:id="rId5"/>
-    <p:sldId id="271" r:id="rId6"/>
-    <p:sldId id="267" r:id="rId7"/>
-    <p:sldId id="272" r:id="rId8"/>
-    <p:sldId id="273" r:id="rId9"/>
-    <p:sldId id="268" r:id="rId10"/>
-    <p:sldId id="269" r:id="rId11"/>
-    <p:sldId id="274" r:id="rId12"/>
-    <p:sldId id="275" r:id="rId13"/>
-    <p:sldId id="278" r:id="rId14"/>
-    <p:sldId id="277" r:id="rId15"/>
-    <p:sldId id="279" r:id="rId16"/>
-    <p:sldId id="270" r:id="rId17"/>
-    <p:sldId id="259" r:id="rId18"/>
-    <p:sldId id="281" r:id="rId19"/>
-    <p:sldId id="282" r:id="rId20"/>
-    <p:sldId id="280" r:id="rId21"/>
-    <p:sldId id="261" r:id="rId22"/>
-    <p:sldId id="263" r:id="rId23"/>
+    <p:sldId id="283" r:id="rId3"/>
+    <p:sldId id="256" r:id="rId4"/>
+    <p:sldId id="257" r:id="rId5"/>
+    <p:sldId id="266" r:id="rId6"/>
+    <p:sldId id="271" r:id="rId7"/>
+    <p:sldId id="267" r:id="rId8"/>
+    <p:sldId id="272" r:id="rId9"/>
+    <p:sldId id="273" r:id="rId10"/>
+    <p:sldId id="268" r:id="rId11"/>
+    <p:sldId id="269" r:id="rId12"/>
+    <p:sldId id="274" r:id="rId13"/>
+    <p:sldId id="275" r:id="rId14"/>
+    <p:sldId id="278" r:id="rId15"/>
+    <p:sldId id="277" r:id="rId16"/>
+    <p:sldId id="279" r:id="rId17"/>
+    <p:sldId id="270" r:id="rId18"/>
+    <p:sldId id="259" r:id="rId19"/>
+    <p:sldId id="281" r:id="rId20"/>
+    <p:sldId id="282" r:id="rId21"/>
+    <p:sldId id="280" r:id="rId22"/>
+    <p:sldId id="261" r:id="rId23"/>
+    <p:sldId id="263" r:id="rId24"/>
   </p:sldIdLst>
   <p:sldSz cx="12192000" cy="6858000"/>
   <p:notesSz cx="6858000" cy="9144000"/>
@@ -669,7 +670,7 @@
           <a:p>
             <a:fld id="{51D417A5-630B-DE42-860C-96747A2C59DE}" type="slidenum">
               <a:rPr lang="en-US" smtClean="0"/>
-              <a:t>12</a:t>
+              <a:t>13</a:t>
             </a:fld>
             <a:endParaRPr lang="en-US"/>
           </a:p>
@@ -777,7 +778,7 @@
           <a:p>
             <a:fld id="{51D417A5-630B-DE42-860C-96747A2C59DE}" type="slidenum">
               <a:rPr lang="en-US" smtClean="0"/>
-              <a:t>13</a:t>
+              <a:t>14</a:t>
             </a:fld>
             <a:endParaRPr lang="en-US"/>
           </a:p>
@@ -885,7 +886,7 @@
           <a:p>
             <a:fld id="{51D417A5-630B-DE42-860C-96747A2C59DE}" type="slidenum">
               <a:rPr lang="en-US" smtClean="0"/>
-              <a:t>14</a:t>
+              <a:t>15</a:t>
             </a:fld>
             <a:endParaRPr lang="en-US"/>
           </a:p>
@@ -993,7 +994,7 @@
           <a:p>
             <a:fld id="{51D417A5-630B-DE42-860C-96747A2C59DE}" type="slidenum">
               <a:rPr lang="en-US" smtClean="0"/>
-              <a:t>15</a:t>
+              <a:t>16</a:t>
             </a:fld>
             <a:endParaRPr lang="en-US"/>
           </a:p>
@@ -1101,7 +1102,7 @@
           <a:p>
             <a:fld id="{51D417A5-630B-DE42-860C-96747A2C59DE}" type="slidenum">
               <a:rPr lang="en-US" smtClean="0"/>
-              <a:t>16</a:t>
+              <a:t>17</a:t>
             </a:fld>
             <a:endParaRPr lang="en-US"/>
           </a:p>
@@ -1185,7 +1186,7 @@
           <a:p>
             <a:fld id="{51D417A5-630B-DE42-860C-96747A2C59DE}" type="slidenum">
               <a:rPr lang="en-US" smtClean="0"/>
-              <a:t>3</a:t>
+              <a:t>4</a:t>
             </a:fld>
             <a:endParaRPr lang="en-US"/>
           </a:p>
@@ -1293,7 +1294,7 @@
           <a:p>
             <a:fld id="{51D417A5-630B-DE42-860C-96747A2C59DE}" type="slidenum">
               <a:rPr lang="en-US" smtClean="0"/>
-              <a:t>5</a:t>
+              <a:t>6</a:t>
             </a:fld>
             <a:endParaRPr lang="en-US"/>
           </a:p>
@@ -1401,7 +1402,7 @@
           <a:p>
             <a:fld id="{51D417A5-630B-DE42-860C-96747A2C59DE}" type="slidenum">
               <a:rPr lang="en-US" smtClean="0"/>
-              <a:t>6</a:t>
+              <a:t>7</a:t>
             </a:fld>
             <a:endParaRPr lang="en-US"/>
           </a:p>
@@ -1509,7 +1510,7 @@
           <a:p>
             <a:fld id="{51D417A5-630B-DE42-860C-96747A2C59DE}" type="slidenum">
               <a:rPr lang="en-US" smtClean="0"/>
-              <a:t>7</a:t>
+              <a:t>8</a:t>
             </a:fld>
             <a:endParaRPr lang="en-US"/>
           </a:p>
@@ -1617,7 +1618,7 @@
           <a:p>
             <a:fld id="{51D417A5-630B-DE42-860C-96747A2C59DE}" type="slidenum">
               <a:rPr lang="en-US" smtClean="0"/>
-              <a:t>8</a:t>
+              <a:t>9</a:t>
             </a:fld>
             <a:endParaRPr lang="en-US"/>
           </a:p>
@@ -1725,7 +1726,7 @@
           <a:p>
             <a:fld id="{51D417A5-630B-DE42-860C-96747A2C59DE}" type="slidenum">
               <a:rPr lang="en-US" smtClean="0"/>
-              <a:t>9</a:t>
+              <a:t>10</a:t>
             </a:fld>
             <a:endParaRPr lang="en-US"/>
           </a:p>
@@ -1833,7 +1834,7 @@
           <a:p>
             <a:fld id="{51D417A5-630B-DE42-860C-96747A2C59DE}" type="slidenum">
               <a:rPr lang="en-US" smtClean="0"/>
-              <a:t>10</a:t>
+              <a:t>11</a:t>
             </a:fld>
             <a:endParaRPr lang="en-US"/>
           </a:p>
@@ -1941,7 +1942,7 @@
           <a:p>
             <a:fld id="{51D417A5-630B-DE42-860C-96747A2C59DE}" type="slidenum">
               <a:rPr lang="en-US" smtClean="0"/>
-              <a:t>11</a:t>
+              <a:t>12</a:t>
             </a:fld>
             <a:endParaRPr lang="en-US"/>
           </a:p>
@@ -5197,7 +5198,7 @@
           <a:p>
             <a:r>
               <a:rPr lang="en-US" dirty="0"/>
-              <a:t>Overview of the day</a:t>
+              <a:t>Welcome! Overview of the day</a:t>
             </a:r>
           </a:p>
         </p:txBody>
@@ -5768,6 +5769,139 @@
         <p:cNvPr id="1" name="">
           <a:extLst>
             <a:ext uri="{FF2B5EF4-FFF2-40B4-BE49-F238E27FC236}">
+              <a16:creationId xmlns:a16="http://schemas.microsoft.com/office/drawing/2014/main" id="{F9812241-244B-055D-95DA-987DF4EAA2D5}"/>
+            </a:ext>
+          </a:extLst>
+        </p:cNvPr>
+        <p:cNvGrpSpPr/>
+        <p:nvPr/>
+      </p:nvGrpSpPr>
+      <p:grpSpPr>
+        <a:xfrm>
+          <a:off x="0" y="0"/>
+          <a:ext cx="0" cy="0"/>
+          <a:chOff x="0" y="0"/>
+          <a:chExt cx="0" cy="0"/>
+        </a:xfrm>
+      </p:grpSpPr>
+      <p:sp>
+        <p:nvSpPr>
+          <p:cNvPr id="2" name="Title 1">
+            <a:extLst>
+              <a:ext uri="{FF2B5EF4-FFF2-40B4-BE49-F238E27FC236}">
+                <a16:creationId xmlns:a16="http://schemas.microsoft.com/office/drawing/2014/main" id="{75FE6AA7-F871-9867-601A-1AAE31E9774B}"/>
+              </a:ext>
+            </a:extLst>
+          </p:cNvPr>
+          <p:cNvSpPr>
+            <a:spLocks noGrp="1"/>
+          </p:cNvSpPr>
+          <p:nvPr>
+            <p:ph type="title"/>
+          </p:nvPr>
+        </p:nvSpPr>
+        <p:spPr/>
+        <p:txBody>
+          <a:bodyPr/>
+          <a:lstStyle/>
+          <a:p>
+            <a:r>
+              <a:rPr lang="en-US" dirty="0"/>
+              <a:t>Modeling mindsets:</a:t>
+            </a:r>
+          </a:p>
+        </p:txBody>
+      </p:sp>
+      <p:sp>
+        <p:nvSpPr>
+          <p:cNvPr id="5" name="TextBox 4">
+            <a:extLst>
+              <a:ext uri="{FF2B5EF4-FFF2-40B4-BE49-F238E27FC236}">
+                <a16:creationId xmlns:a16="http://schemas.microsoft.com/office/drawing/2014/main" id="{0B1164BB-72D5-4A22-DFB6-60343F96D0CA}"/>
+              </a:ext>
+            </a:extLst>
+          </p:cNvPr>
+          <p:cNvSpPr txBox="1"/>
+          <p:nvPr/>
+        </p:nvSpPr>
+        <p:spPr>
+          <a:xfrm>
+            <a:off x="4537276" y="6488668"/>
+            <a:ext cx="8191983" cy="369332"/>
+          </a:xfrm>
+          <a:prstGeom prst="rect">
+            <a:avLst/>
+          </a:prstGeom>
+          <a:noFill/>
+        </p:spPr>
+        <p:txBody>
+          <a:bodyPr wrap="square">
+            <a:spAutoFit/>
+          </a:bodyPr>
+          <a:lstStyle/>
+          <a:p>
+            <a:r>
+              <a:rPr lang="en-US" dirty="0">
+                <a:hlinkClick r:id="rId3"/>
+              </a:rPr>
+              <a:t>Molnar, C. 2023. Modeling mindsets: the many cultures of learning from data.</a:t>
+            </a:r>
+            <a:endParaRPr lang="en-US" dirty="0"/>
+          </a:p>
+        </p:txBody>
+      </p:sp>
+      <p:pic>
+        <p:nvPicPr>
+          <p:cNvPr id="4" name="Picture 3">
+            <a:extLst>
+              <a:ext uri="{FF2B5EF4-FFF2-40B4-BE49-F238E27FC236}">
+                <a16:creationId xmlns:a16="http://schemas.microsoft.com/office/drawing/2014/main" id="{6F15411E-D06D-FD4C-7FF2-987BD7935E9A}"/>
+              </a:ext>
+            </a:extLst>
+          </p:cNvPr>
+          <p:cNvPicPr>
+            <a:picLocks noChangeAspect="1"/>
+          </p:cNvPicPr>
+          <p:nvPr/>
+        </p:nvPicPr>
+        <p:blipFill>
+          <a:blip r:embed="rId4"/>
+          <a:srcRect l="-14" r="105" b="11454"/>
+          <a:stretch>
+            <a:fillRect/>
+          </a:stretch>
+        </p:blipFill>
+        <p:spPr>
+          <a:xfrm>
+            <a:off x="2208628" y="1806292"/>
+            <a:ext cx="7765366" cy="3830580"/>
+          </a:xfrm>
+          <a:prstGeom prst="rect">
+            <a:avLst/>
+          </a:prstGeom>
+        </p:spPr>
+      </p:pic>
+    </p:spTree>
+    <p:extLst>
+      <p:ext uri="{BB962C8B-B14F-4D97-AF65-F5344CB8AC3E}">
+        <p14:creationId xmlns:p14="http://schemas.microsoft.com/office/powerpoint/2010/main" val="3401170566"/>
+      </p:ext>
+    </p:extLst>
+  </p:cSld>
+  <p:clrMapOvr>
+    <a:masterClrMapping/>
+  </p:clrMapOvr>
+</p:sld>
+</file>
+
+<file path=ppt/slides/slide11.xml><?xml version="1.0" encoding="utf-8"?>
+<p:sld xmlns:a="http://schemas.openxmlformats.org/drawingml/2006/main" xmlns:r="http://schemas.openxmlformats.org/officeDocument/2006/relationships" xmlns:p="http://schemas.openxmlformats.org/presentationml/2006/main">
+  <p:cSld>
+    <p:spTree>
+      <p:nvGrpSpPr>
+        <p:cNvPr id="1" name="">
+          <a:extLst>
+            <a:ext uri="{FF2B5EF4-FFF2-40B4-BE49-F238E27FC236}">
               <a16:creationId xmlns:a16="http://schemas.microsoft.com/office/drawing/2014/main" id="{36C20D7A-E356-E09C-8D7C-C12B41C1C3E4}"/>
             </a:ext>
           </a:extLst>
@@ -5893,7 +6027,7 @@
 </p:sld>
 </file>
 
-<file path=ppt/slides/slide11.xml><?xml version="1.0" encoding="utf-8"?>
+<file path=ppt/slides/slide12.xml><?xml version="1.0" encoding="utf-8"?>
 <p:sld xmlns:a="http://schemas.openxmlformats.org/drawingml/2006/main" xmlns:r="http://schemas.openxmlformats.org/officeDocument/2006/relationships" xmlns:p="http://schemas.openxmlformats.org/presentationml/2006/main">
   <p:cSld>
     <p:spTree>
@@ -6065,7 +6199,7 @@
 </p:sld>
 </file>
 
-<file path=ppt/slides/slide12.xml><?xml version="1.0" encoding="utf-8"?>
+<file path=ppt/slides/slide13.xml><?xml version="1.0" encoding="utf-8"?>
 <p:sld xmlns:a="http://schemas.openxmlformats.org/drawingml/2006/main" xmlns:r="http://schemas.openxmlformats.org/officeDocument/2006/relationships" xmlns:p="http://schemas.openxmlformats.org/presentationml/2006/main">
   <p:cSld>
     <p:spTree>
@@ -6278,7 +6412,7 @@
 </p:sld>
 </file>
 
-<file path=ppt/slides/slide13.xml><?xml version="1.0" encoding="utf-8"?>
+<file path=ppt/slides/slide14.xml><?xml version="1.0" encoding="utf-8"?>
 <p:sld xmlns:a="http://schemas.openxmlformats.org/drawingml/2006/main" xmlns:r="http://schemas.openxmlformats.org/officeDocument/2006/relationships" xmlns:p="http://schemas.openxmlformats.org/presentationml/2006/main">
   <p:cSld>
     <p:spTree>
@@ -6532,7 +6666,7 @@
 </p:sld>
 </file>
 
-<file path=ppt/slides/slide14.xml><?xml version="1.0" encoding="utf-8"?>
+<file path=ppt/slides/slide15.xml><?xml version="1.0" encoding="utf-8"?>
 <p:sld xmlns:a="http://schemas.openxmlformats.org/drawingml/2006/main" xmlns:r="http://schemas.openxmlformats.org/officeDocument/2006/relationships" xmlns:p="http://schemas.openxmlformats.org/presentationml/2006/main">
   <p:cSld>
     <p:spTree>
@@ -6827,7 +6961,7 @@
 </p:sld>
 </file>
 
-<file path=ppt/slides/slide15.xml><?xml version="1.0" encoding="utf-8"?>
+<file path=ppt/slides/slide16.xml><?xml version="1.0" encoding="utf-8"?>
 <p:sld xmlns:a="http://schemas.openxmlformats.org/drawingml/2006/main" xmlns:r="http://schemas.openxmlformats.org/officeDocument/2006/relationships" xmlns:p="http://schemas.openxmlformats.org/presentationml/2006/main">
   <p:cSld>
     <p:spTree>
@@ -7056,7 +7190,7 @@
 </p:sld>
 </file>
 
-<file path=ppt/slides/slide16.xml><?xml version="1.0" encoding="utf-8"?>
+<file path=ppt/slides/slide17.xml><?xml version="1.0" encoding="utf-8"?>
 <p:sld xmlns:a="http://schemas.openxmlformats.org/drawingml/2006/main" xmlns:r="http://schemas.openxmlformats.org/officeDocument/2006/relationships" xmlns:p="http://schemas.openxmlformats.org/presentationml/2006/main">
   <p:cSld>
     <p:spTree>
@@ -7951,7 +8085,7 @@
 </p:sld>
 </file>
 
-<file path=ppt/slides/slide17.xml><?xml version="1.0" encoding="utf-8"?>
+<file path=ppt/slides/slide18.xml><?xml version="1.0" encoding="utf-8"?>
 <p:sld xmlns:a="http://schemas.openxmlformats.org/drawingml/2006/main" xmlns:r="http://schemas.openxmlformats.org/officeDocument/2006/relationships" xmlns:p="http://schemas.openxmlformats.org/presentationml/2006/main">
   <p:cSld>
     <p:spTree>
@@ -8071,7 +8205,7 @@
 </p:sld>
 </file>
 
-<file path=ppt/slides/slide18.xml><?xml version="1.0" encoding="utf-8"?>
+<file path=ppt/slides/slide19.xml><?xml version="1.0" encoding="utf-8"?>
 <p:sld xmlns:a="http://schemas.openxmlformats.org/drawingml/2006/main" xmlns:r="http://schemas.openxmlformats.org/officeDocument/2006/relationships" xmlns:p="http://schemas.openxmlformats.org/presentationml/2006/main">
   <p:cSld>
     <p:spTree>
@@ -8474,7 +8608,90 @@
 </p:sld>
 </file>
 
-<file path=ppt/slides/slide19.xml><?xml version="1.0" encoding="utf-8"?>
+<file path=ppt/slides/slide2.xml><?xml version="1.0" encoding="utf-8"?>
+<p:sld xmlns:a="http://schemas.openxmlformats.org/drawingml/2006/main" xmlns:r="http://schemas.openxmlformats.org/officeDocument/2006/relationships" xmlns:p="http://schemas.openxmlformats.org/presentationml/2006/main">
+  <p:cSld>
+    <p:spTree>
+      <p:nvGrpSpPr>
+        <p:cNvPr id="1" name=""/>
+        <p:cNvGrpSpPr/>
+        <p:nvPr/>
+      </p:nvGrpSpPr>
+      <p:grpSpPr>
+        <a:xfrm>
+          <a:off x="0" y="0"/>
+          <a:ext cx="0" cy="0"/>
+          <a:chOff x="0" y="0"/>
+          <a:chExt cx="0" cy="0"/>
+        </a:xfrm>
+      </p:grpSpPr>
+      <p:sp>
+        <p:nvSpPr>
+          <p:cNvPr id="2" name="Title 1">
+            <a:extLst>
+              <a:ext uri="{FF2B5EF4-FFF2-40B4-BE49-F238E27FC236}">
+                <a16:creationId xmlns:a16="http://schemas.microsoft.com/office/drawing/2014/main" id="{9BEB7C61-DC98-CC3C-8E5A-B2AF4CD8BBE2}"/>
+              </a:ext>
+            </a:extLst>
+          </p:cNvPr>
+          <p:cNvSpPr>
+            <a:spLocks noGrp="1"/>
+          </p:cNvSpPr>
+          <p:nvPr>
+            <p:ph type="title"/>
+          </p:nvPr>
+        </p:nvSpPr>
+        <p:spPr/>
+        <p:txBody>
+          <a:bodyPr/>
+          <a:lstStyle/>
+          <a:p>
+            <a:r>
+              <a:rPr lang="en-US"/>
+              <a:t>ADD INTROS	</a:t>
+            </a:r>
+          </a:p>
+        </p:txBody>
+      </p:sp>
+      <p:sp>
+        <p:nvSpPr>
+          <p:cNvPr id="3" name="Content Placeholder 2">
+            <a:extLst>
+              <a:ext uri="{FF2B5EF4-FFF2-40B4-BE49-F238E27FC236}">
+                <a16:creationId xmlns:a16="http://schemas.microsoft.com/office/drawing/2014/main" id="{F106FC64-C12D-7AF3-66EA-511A1D62010F}"/>
+              </a:ext>
+            </a:extLst>
+          </p:cNvPr>
+          <p:cNvSpPr>
+            <a:spLocks noGrp="1"/>
+          </p:cNvSpPr>
+          <p:nvPr>
+            <p:ph idx="1"/>
+          </p:nvPr>
+        </p:nvSpPr>
+        <p:spPr/>
+        <p:txBody>
+          <a:bodyPr/>
+          <a:lstStyle/>
+          <a:p>
+            <a:endParaRPr lang="en-US"/>
+          </a:p>
+        </p:txBody>
+      </p:sp>
+    </p:spTree>
+    <p:extLst>
+      <p:ext uri="{BB962C8B-B14F-4D97-AF65-F5344CB8AC3E}">
+        <p14:creationId xmlns:p14="http://schemas.microsoft.com/office/powerpoint/2010/main" val="3116746417"/>
+      </p:ext>
+    </p:extLst>
+  </p:cSld>
+  <p:clrMapOvr>
+    <a:masterClrMapping/>
+  </p:clrMapOvr>
+</p:sld>
+</file>
+
+<file path=ppt/slides/slide20.xml><?xml version="1.0" encoding="utf-8"?>
 <p:sld xmlns:a="http://schemas.openxmlformats.org/drawingml/2006/main" xmlns:r="http://schemas.openxmlformats.org/officeDocument/2006/relationships" xmlns:p="http://schemas.openxmlformats.org/presentationml/2006/main">
   <p:cSld>
     <p:spTree>
@@ -8678,305 +8895,7 @@
 </p:sld>
 </file>
 
-<file path=ppt/slides/slide2.xml><?xml version="1.0" encoding="utf-8"?>
-<p:sld xmlns:a="http://schemas.openxmlformats.org/drawingml/2006/main" xmlns:r="http://schemas.openxmlformats.org/officeDocument/2006/relationships" xmlns:p="http://schemas.openxmlformats.org/presentationml/2006/main">
-  <p:cSld>
-    <p:spTree>
-      <p:nvGrpSpPr>
-        <p:cNvPr id="1" name=""/>
-        <p:cNvGrpSpPr/>
-        <p:nvPr/>
-      </p:nvGrpSpPr>
-      <p:grpSpPr>
-        <a:xfrm>
-          <a:off x="0" y="0"/>
-          <a:ext cx="0" cy="0"/>
-          <a:chOff x="0" y="0"/>
-          <a:chExt cx="0" cy="0"/>
-        </a:xfrm>
-      </p:grpSpPr>
-      <p:sp>
-        <p:nvSpPr>
-          <p:cNvPr id="2" name="Title 1">
-            <a:extLst>
-              <a:ext uri="{FF2B5EF4-FFF2-40B4-BE49-F238E27FC236}">
-                <a16:creationId xmlns:a16="http://schemas.microsoft.com/office/drawing/2014/main" id="{47CF43D2-AABB-3923-A21F-941815B0A9E9}"/>
-              </a:ext>
-            </a:extLst>
-          </p:cNvPr>
-          <p:cNvSpPr>
-            <a:spLocks noGrp="1"/>
-          </p:cNvSpPr>
-          <p:nvPr>
-            <p:ph type="ctrTitle"/>
-          </p:nvPr>
-        </p:nvSpPr>
-        <p:spPr/>
-        <p:txBody>
-          <a:bodyPr/>
-          <a:lstStyle/>
-          <a:p>
-            <a:r>
-              <a:rPr lang="en-US" dirty="0"/>
-              <a:t>What is machine learning?</a:t>
-            </a:r>
-          </a:p>
-        </p:txBody>
-      </p:sp>
-      <p:sp>
-        <p:nvSpPr>
-          <p:cNvPr id="3" name="Subtitle 2">
-            <a:extLst>
-              <a:ext uri="{FF2B5EF4-FFF2-40B4-BE49-F238E27FC236}">
-                <a16:creationId xmlns:a16="http://schemas.microsoft.com/office/drawing/2014/main" id="{9E839DD3-C76D-C5AD-AC5D-13F2B28B5729}"/>
-              </a:ext>
-            </a:extLst>
-          </p:cNvPr>
-          <p:cNvSpPr>
-            <a:spLocks noGrp="1"/>
-          </p:cNvSpPr>
-          <p:nvPr>
-            <p:ph type="subTitle" idx="1"/>
-          </p:nvPr>
-        </p:nvSpPr>
-        <p:spPr>
-          <a:xfrm>
-            <a:off x="1524000" y="3602038"/>
-            <a:ext cx="9144000" cy="472251"/>
-          </a:xfrm>
-        </p:spPr>
-        <p:txBody>
-          <a:bodyPr/>
-          <a:lstStyle/>
-          <a:p>
-            <a:r>
-              <a:rPr lang="en-US" dirty="0"/>
-              <a:t>And why is it useful (for science)?</a:t>
-            </a:r>
-          </a:p>
-        </p:txBody>
-      </p:sp>
-      <p:sp>
-        <p:nvSpPr>
-          <p:cNvPr id="4" name="Subtitle 2">
-            <a:extLst>
-              <a:ext uri="{FF2B5EF4-FFF2-40B4-BE49-F238E27FC236}">
-                <a16:creationId xmlns:a16="http://schemas.microsoft.com/office/drawing/2014/main" id="{7A84C9FD-C48D-1312-800B-AD902ED34D44}"/>
-              </a:ext>
-            </a:extLst>
-          </p:cNvPr>
-          <p:cNvSpPr txBox="1">
-            <a:spLocks/>
-          </p:cNvSpPr>
-          <p:nvPr/>
-        </p:nvSpPr>
-        <p:spPr>
-          <a:xfrm>
-            <a:off x="1524000" y="4310023"/>
-            <a:ext cx="9144000" cy="472251"/>
-          </a:xfrm>
-          <a:prstGeom prst="rect">
-            <a:avLst/>
-          </a:prstGeom>
-        </p:spPr>
-        <p:txBody>
-          <a:bodyPr vert="horz" lIns="91440" tIns="45720" rIns="91440" bIns="45720" rtlCol="0">
-            <a:normAutofit/>
-          </a:bodyPr>
-          <a:lstStyle>
-            <a:lvl1pPr marL="0" indent="0" algn="ctr" defTabSz="914400" rtl="0" eaLnBrk="1" latinLnBrk="0" hangingPunct="1">
-              <a:lnSpc>
-                <a:spcPct val="90000"/>
-              </a:lnSpc>
-              <a:spcBef>
-                <a:spcPts val="1000"/>
-              </a:spcBef>
-              <a:buFont typeface="Arial" panose="020B0604020202020204" pitchFamily="34" charset="0"/>
-              <a:buNone/>
-              <a:defRPr sz="2400" kern="1200">
-                <a:solidFill>
-                  <a:schemeClr val="tx1"/>
-                </a:solidFill>
-                <a:latin typeface="+mn-lt"/>
-                <a:ea typeface="+mn-ea"/>
-                <a:cs typeface="+mn-cs"/>
-              </a:defRPr>
-            </a:lvl1pPr>
-            <a:lvl2pPr marL="457200" indent="0" algn="ctr" defTabSz="914400" rtl="0" eaLnBrk="1" latinLnBrk="0" hangingPunct="1">
-              <a:lnSpc>
-                <a:spcPct val="90000"/>
-              </a:lnSpc>
-              <a:spcBef>
-                <a:spcPts val="500"/>
-              </a:spcBef>
-              <a:buFont typeface="Arial" panose="020B0604020202020204" pitchFamily="34" charset="0"/>
-              <a:buNone/>
-              <a:defRPr sz="2000" kern="1200">
-                <a:solidFill>
-                  <a:schemeClr val="tx1"/>
-                </a:solidFill>
-                <a:latin typeface="+mn-lt"/>
-                <a:ea typeface="+mn-ea"/>
-                <a:cs typeface="+mn-cs"/>
-              </a:defRPr>
-            </a:lvl2pPr>
-            <a:lvl3pPr marL="914400" indent="0" algn="ctr" defTabSz="914400" rtl="0" eaLnBrk="1" latinLnBrk="0" hangingPunct="1">
-              <a:lnSpc>
-                <a:spcPct val="90000"/>
-              </a:lnSpc>
-              <a:spcBef>
-                <a:spcPts val="500"/>
-              </a:spcBef>
-              <a:buFont typeface="Arial" panose="020B0604020202020204" pitchFamily="34" charset="0"/>
-              <a:buNone/>
-              <a:defRPr sz="1800" kern="1200">
-                <a:solidFill>
-                  <a:schemeClr val="tx1"/>
-                </a:solidFill>
-                <a:latin typeface="+mn-lt"/>
-                <a:ea typeface="+mn-ea"/>
-                <a:cs typeface="+mn-cs"/>
-              </a:defRPr>
-            </a:lvl3pPr>
-            <a:lvl4pPr marL="1371600" indent="0" algn="ctr" defTabSz="914400" rtl="0" eaLnBrk="1" latinLnBrk="0" hangingPunct="1">
-              <a:lnSpc>
-                <a:spcPct val="90000"/>
-              </a:lnSpc>
-              <a:spcBef>
-                <a:spcPts val="500"/>
-              </a:spcBef>
-              <a:buFont typeface="Arial" panose="020B0604020202020204" pitchFamily="34" charset="0"/>
-              <a:buNone/>
-              <a:defRPr sz="1600" kern="1200">
-                <a:solidFill>
-                  <a:schemeClr val="tx1"/>
-                </a:solidFill>
-                <a:latin typeface="+mn-lt"/>
-                <a:ea typeface="+mn-ea"/>
-                <a:cs typeface="+mn-cs"/>
-              </a:defRPr>
-            </a:lvl4pPr>
-            <a:lvl5pPr marL="1828800" indent="0" algn="ctr" defTabSz="914400" rtl="0" eaLnBrk="1" latinLnBrk="0" hangingPunct="1">
-              <a:lnSpc>
-                <a:spcPct val="90000"/>
-              </a:lnSpc>
-              <a:spcBef>
-                <a:spcPts val="500"/>
-              </a:spcBef>
-              <a:buFont typeface="Arial" panose="020B0604020202020204" pitchFamily="34" charset="0"/>
-              <a:buNone/>
-              <a:defRPr sz="1600" kern="1200">
-                <a:solidFill>
-                  <a:schemeClr val="tx1"/>
-                </a:solidFill>
-                <a:latin typeface="+mn-lt"/>
-                <a:ea typeface="+mn-ea"/>
-                <a:cs typeface="+mn-cs"/>
-              </a:defRPr>
-            </a:lvl5pPr>
-            <a:lvl6pPr marL="2286000" indent="0" algn="ctr" defTabSz="914400" rtl="0" eaLnBrk="1" latinLnBrk="0" hangingPunct="1">
-              <a:lnSpc>
-                <a:spcPct val="90000"/>
-              </a:lnSpc>
-              <a:spcBef>
-                <a:spcPts val="500"/>
-              </a:spcBef>
-              <a:buFont typeface="Arial" panose="020B0604020202020204" pitchFamily="34" charset="0"/>
-              <a:buNone/>
-              <a:defRPr sz="1600" kern="1200">
-                <a:solidFill>
-                  <a:schemeClr val="tx1"/>
-                </a:solidFill>
-                <a:latin typeface="+mn-lt"/>
-                <a:ea typeface="+mn-ea"/>
-                <a:cs typeface="+mn-cs"/>
-              </a:defRPr>
-            </a:lvl6pPr>
-            <a:lvl7pPr marL="2743200" indent="0" algn="ctr" defTabSz="914400" rtl="0" eaLnBrk="1" latinLnBrk="0" hangingPunct="1">
-              <a:lnSpc>
-                <a:spcPct val="90000"/>
-              </a:lnSpc>
-              <a:spcBef>
-                <a:spcPts val="500"/>
-              </a:spcBef>
-              <a:buFont typeface="Arial" panose="020B0604020202020204" pitchFamily="34" charset="0"/>
-              <a:buNone/>
-              <a:defRPr sz="1600" kern="1200">
-                <a:solidFill>
-                  <a:schemeClr val="tx1"/>
-                </a:solidFill>
-                <a:latin typeface="+mn-lt"/>
-                <a:ea typeface="+mn-ea"/>
-                <a:cs typeface="+mn-cs"/>
-              </a:defRPr>
-            </a:lvl7pPr>
-            <a:lvl8pPr marL="3200400" indent="0" algn="ctr" defTabSz="914400" rtl="0" eaLnBrk="1" latinLnBrk="0" hangingPunct="1">
-              <a:lnSpc>
-                <a:spcPct val="90000"/>
-              </a:lnSpc>
-              <a:spcBef>
-                <a:spcPts val="500"/>
-              </a:spcBef>
-              <a:buFont typeface="Arial" panose="020B0604020202020204" pitchFamily="34" charset="0"/>
-              <a:buNone/>
-              <a:defRPr sz="1600" kern="1200">
-                <a:solidFill>
-                  <a:schemeClr val="tx1"/>
-                </a:solidFill>
-                <a:latin typeface="+mn-lt"/>
-                <a:ea typeface="+mn-ea"/>
-                <a:cs typeface="+mn-cs"/>
-              </a:defRPr>
-            </a:lvl8pPr>
-            <a:lvl9pPr marL="3657600" indent="0" algn="ctr" defTabSz="914400" rtl="0" eaLnBrk="1" latinLnBrk="0" hangingPunct="1">
-              <a:lnSpc>
-                <a:spcPct val="90000"/>
-              </a:lnSpc>
-              <a:spcBef>
-                <a:spcPts val="500"/>
-              </a:spcBef>
-              <a:buFont typeface="Arial" panose="020B0604020202020204" pitchFamily="34" charset="0"/>
-              <a:buNone/>
-              <a:defRPr sz="1600" kern="1200">
-                <a:solidFill>
-                  <a:schemeClr val="tx1"/>
-                </a:solidFill>
-                <a:latin typeface="+mn-lt"/>
-                <a:ea typeface="+mn-ea"/>
-                <a:cs typeface="+mn-cs"/>
-              </a:defRPr>
-            </a:lvl9pPr>
-          </a:lstStyle>
-          <a:p>
-            <a:r>
-              <a:rPr lang="en-US" dirty="0"/>
-              <a:t>Grant Vagle, Jeremiah </a:t>
-            </a:r>
-            <a:r>
-              <a:rPr lang="en-US" dirty="0" err="1"/>
-              <a:t>Shrovnal</a:t>
-            </a:r>
-            <a:r>
-              <a:rPr lang="en-US" dirty="0"/>
-              <a:t>, Lynn Waterhouse</a:t>
-            </a:r>
-          </a:p>
-        </p:txBody>
-      </p:sp>
-    </p:spTree>
-    <p:extLst>
-      <p:ext uri="{BB962C8B-B14F-4D97-AF65-F5344CB8AC3E}">
-        <p14:creationId xmlns:p14="http://schemas.microsoft.com/office/powerpoint/2010/main" val="973311027"/>
-      </p:ext>
-    </p:extLst>
-  </p:cSld>
-  <p:clrMapOvr>
-    <a:masterClrMapping/>
-  </p:clrMapOvr>
-</p:sld>
-</file>
-
-<file path=ppt/slides/slide20.xml><?xml version="1.0" encoding="utf-8"?>
+<file path=ppt/slides/slide21.xml><?xml version="1.0" encoding="utf-8"?>
 <p:sld xmlns:a="http://schemas.openxmlformats.org/drawingml/2006/main" xmlns:r="http://schemas.openxmlformats.org/officeDocument/2006/relationships" xmlns:p="http://schemas.openxmlformats.org/presentationml/2006/main">
   <p:cSld>
     <p:spTree>
@@ -9811,7 +9730,7 @@
 </p:sld>
 </file>
 
-<file path=ppt/slides/slide21.xml><?xml version="1.0" encoding="utf-8"?>
+<file path=ppt/slides/slide22.xml><?xml version="1.0" encoding="utf-8"?>
 <p:sld xmlns:a="http://schemas.openxmlformats.org/drawingml/2006/main" xmlns:r="http://schemas.openxmlformats.org/officeDocument/2006/relationships" xmlns:p="http://schemas.openxmlformats.org/presentationml/2006/main">
   <p:cSld>
     <p:spTree>
@@ -9968,7 +9887,7 @@
         </p:spPr>
         <p:txBody>
           <a:bodyPr vert="horz" lIns="91440" tIns="45720" rIns="91440" bIns="45720" rtlCol="0">
-            <a:normAutofit lnSpcReduction="10000"/>
+            <a:normAutofit fontScale="92500"/>
           </a:bodyPr>
           <a:lstStyle>
             <a:lvl1pPr marL="228600" indent="-228600" algn="l" defTabSz="914400" rtl="0" eaLnBrk="1" latinLnBrk="0" hangingPunct="1">
@@ -10177,6 +10096,12 @@
           <a:p>
             <a:r>
               <a:rPr lang="en-US" dirty="0"/>
+              <a:t>Bayesian Additive Regression Trees</a:t>
+            </a:r>
+          </a:p>
+          <a:p>
+            <a:r>
+              <a:rPr lang="en-US" dirty="0"/>
               <a:t>All the possible interpretation methods</a:t>
             </a:r>
           </a:p>
@@ -10195,7 +10120,7 @@
 </p:sld>
 </file>
 
-<file path=ppt/slides/slide22.xml><?xml version="1.0" encoding="utf-8"?>
+<file path=ppt/slides/slide23.xml><?xml version="1.0" encoding="utf-8"?>
 <p:sld xmlns:a="http://schemas.openxmlformats.org/drawingml/2006/main" xmlns:r="http://schemas.openxmlformats.org/officeDocument/2006/relationships" xmlns:p="http://schemas.openxmlformats.org/presentationml/2006/main">
   <p:cSld>
     <p:spTree>
@@ -10408,6 +10333,304 @@
           <p:cNvPr id="2" name="Title 1">
             <a:extLst>
               <a:ext uri="{FF2B5EF4-FFF2-40B4-BE49-F238E27FC236}">
+                <a16:creationId xmlns:a16="http://schemas.microsoft.com/office/drawing/2014/main" id="{47CF43D2-AABB-3923-A21F-941815B0A9E9}"/>
+              </a:ext>
+            </a:extLst>
+          </p:cNvPr>
+          <p:cNvSpPr>
+            <a:spLocks noGrp="1"/>
+          </p:cNvSpPr>
+          <p:nvPr>
+            <p:ph type="ctrTitle"/>
+          </p:nvPr>
+        </p:nvSpPr>
+        <p:spPr/>
+        <p:txBody>
+          <a:bodyPr/>
+          <a:lstStyle/>
+          <a:p>
+            <a:r>
+              <a:rPr lang="en-US" dirty="0"/>
+              <a:t>What is machine learning?</a:t>
+            </a:r>
+          </a:p>
+        </p:txBody>
+      </p:sp>
+      <p:sp>
+        <p:nvSpPr>
+          <p:cNvPr id="3" name="Subtitle 2">
+            <a:extLst>
+              <a:ext uri="{FF2B5EF4-FFF2-40B4-BE49-F238E27FC236}">
+                <a16:creationId xmlns:a16="http://schemas.microsoft.com/office/drawing/2014/main" id="{9E839DD3-C76D-C5AD-AC5D-13F2B28B5729}"/>
+              </a:ext>
+            </a:extLst>
+          </p:cNvPr>
+          <p:cNvSpPr>
+            <a:spLocks noGrp="1"/>
+          </p:cNvSpPr>
+          <p:nvPr>
+            <p:ph type="subTitle" idx="1"/>
+          </p:nvPr>
+        </p:nvSpPr>
+        <p:spPr>
+          <a:xfrm>
+            <a:off x="1524000" y="3602038"/>
+            <a:ext cx="9144000" cy="472251"/>
+          </a:xfrm>
+        </p:spPr>
+        <p:txBody>
+          <a:bodyPr/>
+          <a:lstStyle/>
+          <a:p>
+            <a:r>
+              <a:rPr lang="en-US" dirty="0"/>
+              <a:t>And why is it useful (for science)?</a:t>
+            </a:r>
+          </a:p>
+        </p:txBody>
+      </p:sp>
+      <p:sp>
+        <p:nvSpPr>
+          <p:cNvPr id="4" name="Subtitle 2">
+            <a:extLst>
+              <a:ext uri="{FF2B5EF4-FFF2-40B4-BE49-F238E27FC236}">
+                <a16:creationId xmlns:a16="http://schemas.microsoft.com/office/drawing/2014/main" id="{7A84C9FD-C48D-1312-800B-AD902ED34D44}"/>
+              </a:ext>
+            </a:extLst>
+          </p:cNvPr>
+          <p:cNvSpPr txBox="1">
+            <a:spLocks/>
+          </p:cNvSpPr>
+          <p:nvPr/>
+        </p:nvSpPr>
+        <p:spPr>
+          <a:xfrm>
+            <a:off x="1524000" y="4310023"/>
+            <a:ext cx="9144000" cy="472251"/>
+          </a:xfrm>
+          <a:prstGeom prst="rect">
+            <a:avLst/>
+          </a:prstGeom>
+        </p:spPr>
+        <p:txBody>
+          <a:bodyPr vert="horz" lIns="91440" tIns="45720" rIns="91440" bIns="45720" rtlCol="0">
+            <a:normAutofit/>
+          </a:bodyPr>
+          <a:lstStyle>
+            <a:lvl1pPr marL="0" indent="0" algn="ctr" defTabSz="914400" rtl="0" eaLnBrk="1" latinLnBrk="0" hangingPunct="1">
+              <a:lnSpc>
+                <a:spcPct val="90000"/>
+              </a:lnSpc>
+              <a:spcBef>
+                <a:spcPts val="1000"/>
+              </a:spcBef>
+              <a:buFont typeface="Arial" panose="020B0604020202020204" pitchFamily="34" charset="0"/>
+              <a:buNone/>
+              <a:defRPr sz="2400" kern="1200">
+                <a:solidFill>
+                  <a:schemeClr val="tx1"/>
+                </a:solidFill>
+                <a:latin typeface="+mn-lt"/>
+                <a:ea typeface="+mn-ea"/>
+                <a:cs typeface="+mn-cs"/>
+              </a:defRPr>
+            </a:lvl1pPr>
+            <a:lvl2pPr marL="457200" indent="0" algn="ctr" defTabSz="914400" rtl="0" eaLnBrk="1" latinLnBrk="0" hangingPunct="1">
+              <a:lnSpc>
+                <a:spcPct val="90000"/>
+              </a:lnSpc>
+              <a:spcBef>
+                <a:spcPts val="500"/>
+              </a:spcBef>
+              <a:buFont typeface="Arial" panose="020B0604020202020204" pitchFamily="34" charset="0"/>
+              <a:buNone/>
+              <a:defRPr sz="2000" kern="1200">
+                <a:solidFill>
+                  <a:schemeClr val="tx1"/>
+                </a:solidFill>
+                <a:latin typeface="+mn-lt"/>
+                <a:ea typeface="+mn-ea"/>
+                <a:cs typeface="+mn-cs"/>
+              </a:defRPr>
+            </a:lvl2pPr>
+            <a:lvl3pPr marL="914400" indent="0" algn="ctr" defTabSz="914400" rtl="0" eaLnBrk="1" latinLnBrk="0" hangingPunct="1">
+              <a:lnSpc>
+                <a:spcPct val="90000"/>
+              </a:lnSpc>
+              <a:spcBef>
+                <a:spcPts val="500"/>
+              </a:spcBef>
+              <a:buFont typeface="Arial" panose="020B0604020202020204" pitchFamily="34" charset="0"/>
+              <a:buNone/>
+              <a:defRPr sz="1800" kern="1200">
+                <a:solidFill>
+                  <a:schemeClr val="tx1"/>
+                </a:solidFill>
+                <a:latin typeface="+mn-lt"/>
+                <a:ea typeface="+mn-ea"/>
+                <a:cs typeface="+mn-cs"/>
+              </a:defRPr>
+            </a:lvl3pPr>
+            <a:lvl4pPr marL="1371600" indent="0" algn="ctr" defTabSz="914400" rtl="0" eaLnBrk="1" latinLnBrk="0" hangingPunct="1">
+              <a:lnSpc>
+                <a:spcPct val="90000"/>
+              </a:lnSpc>
+              <a:spcBef>
+                <a:spcPts val="500"/>
+              </a:spcBef>
+              <a:buFont typeface="Arial" panose="020B0604020202020204" pitchFamily="34" charset="0"/>
+              <a:buNone/>
+              <a:defRPr sz="1600" kern="1200">
+                <a:solidFill>
+                  <a:schemeClr val="tx1"/>
+                </a:solidFill>
+                <a:latin typeface="+mn-lt"/>
+                <a:ea typeface="+mn-ea"/>
+                <a:cs typeface="+mn-cs"/>
+              </a:defRPr>
+            </a:lvl4pPr>
+            <a:lvl5pPr marL="1828800" indent="0" algn="ctr" defTabSz="914400" rtl="0" eaLnBrk="1" latinLnBrk="0" hangingPunct="1">
+              <a:lnSpc>
+                <a:spcPct val="90000"/>
+              </a:lnSpc>
+              <a:spcBef>
+                <a:spcPts val="500"/>
+              </a:spcBef>
+              <a:buFont typeface="Arial" panose="020B0604020202020204" pitchFamily="34" charset="0"/>
+              <a:buNone/>
+              <a:defRPr sz="1600" kern="1200">
+                <a:solidFill>
+                  <a:schemeClr val="tx1"/>
+                </a:solidFill>
+                <a:latin typeface="+mn-lt"/>
+                <a:ea typeface="+mn-ea"/>
+                <a:cs typeface="+mn-cs"/>
+              </a:defRPr>
+            </a:lvl5pPr>
+            <a:lvl6pPr marL="2286000" indent="0" algn="ctr" defTabSz="914400" rtl="0" eaLnBrk="1" latinLnBrk="0" hangingPunct="1">
+              <a:lnSpc>
+                <a:spcPct val="90000"/>
+              </a:lnSpc>
+              <a:spcBef>
+                <a:spcPts val="500"/>
+              </a:spcBef>
+              <a:buFont typeface="Arial" panose="020B0604020202020204" pitchFamily="34" charset="0"/>
+              <a:buNone/>
+              <a:defRPr sz="1600" kern="1200">
+                <a:solidFill>
+                  <a:schemeClr val="tx1"/>
+                </a:solidFill>
+                <a:latin typeface="+mn-lt"/>
+                <a:ea typeface="+mn-ea"/>
+                <a:cs typeface="+mn-cs"/>
+              </a:defRPr>
+            </a:lvl6pPr>
+            <a:lvl7pPr marL="2743200" indent="0" algn="ctr" defTabSz="914400" rtl="0" eaLnBrk="1" latinLnBrk="0" hangingPunct="1">
+              <a:lnSpc>
+                <a:spcPct val="90000"/>
+              </a:lnSpc>
+              <a:spcBef>
+                <a:spcPts val="500"/>
+              </a:spcBef>
+              <a:buFont typeface="Arial" panose="020B0604020202020204" pitchFamily="34" charset="0"/>
+              <a:buNone/>
+              <a:defRPr sz="1600" kern="1200">
+                <a:solidFill>
+                  <a:schemeClr val="tx1"/>
+                </a:solidFill>
+                <a:latin typeface="+mn-lt"/>
+                <a:ea typeface="+mn-ea"/>
+                <a:cs typeface="+mn-cs"/>
+              </a:defRPr>
+            </a:lvl7pPr>
+            <a:lvl8pPr marL="3200400" indent="0" algn="ctr" defTabSz="914400" rtl="0" eaLnBrk="1" latinLnBrk="0" hangingPunct="1">
+              <a:lnSpc>
+                <a:spcPct val="90000"/>
+              </a:lnSpc>
+              <a:spcBef>
+                <a:spcPts val="500"/>
+              </a:spcBef>
+              <a:buFont typeface="Arial" panose="020B0604020202020204" pitchFamily="34" charset="0"/>
+              <a:buNone/>
+              <a:defRPr sz="1600" kern="1200">
+                <a:solidFill>
+                  <a:schemeClr val="tx1"/>
+                </a:solidFill>
+                <a:latin typeface="+mn-lt"/>
+                <a:ea typeface="+mn-ea"/>
+                <a:cs typeface="+mn-cs"/>
+              </a:defRPr>
+            </a:lvl8pPr>
+            <a:lvl9pPr marL="3657600" indent="0" algn="ctr" defTabSz="914400" rtl="0" eaLnBrk="1" latinLnBrk="0" hangingPunct="1">
+              <a:lnSpc>
+                <a:spcPct val="90000"/>
+              </a:lnSpc>
+              <a:spcBef>
+                <a:spcPts val="500"/>
+              </a:spcBef>
+              <a:buFont typeface="Arial" panose="020B0604020202020204" pitchFamily="34" charset="0"/>
+              <a:buNone/>
+              <a:defRPr sz="1600" kern="1200">
+                <a:solidFill>
+                  <a:schemeClr val="tx1"/>
+                </a:solidFill>
+                <a:latin typeface="+mn-lt"/>
+                <a:ea typeface="+mn-ea"/>
+                <a:cs typeface="+mn-cs"/>
+              </a:defRPr>
+            </a:lvl9pPr>
+          </a:lstStyle>
+          <a:p>
+            <a:r>
+              <a:rPr lang="en-US" dirty="0"/>
+              <a:t>Grant Vagle, Jeremiah </a:t>
+            </a:r>
+            <a:r>
+              <a:rPr lang="en-US" dirty="0" err="1"/>
+              <a:t>Shrovnal</a:t>
+            </a:r>
+            <a:r>
+              <a:rPr lang="en-US" dirty="0"/>
+              <a:t>, Lynn Waterhouse</a:t>
+            </a:r>
+          </a:p>
+        </p:txBody>
+      </p:sp>
+    </p:spTree>
+    <p:extLst>
+      <p:ext uri="{BB962C8B-B14F-4D97-AF65-F5344CB8AC3E}">
+        <p14:creationId xmlns:p14="http://schemas.microsoft.com/office/powerpoint/2010/main" val="973311027"/>
+      </p:ext>
+    </p:extLst>
+  </p:cSld>
+  <p:clrMapOvr>
+    <a:masterClrMapping/>
+  </p:clrMapOvr>
+</p:sld>
+</file>
+
+<file path=ppt/slides/slide4.xml><?xml version="1.0" encoding="utf-8"?>
+<p:sld xmlns:a="http://schemas.openxmlformats.org/drawingml/2006/main" xmlns:r="http://schemas.openxmlformats.org/officeDocument/2006/relationships" xmlns:p="http://schemas.openxmlformats.org/presentationml/2006/main">
+  <p:cSld>
+    <p:spTree>
+      <p:nvGrpSpPr>
+        <p:cNvPr id="1" name=""/>
+        <p:cNvGrpSpPr/>
+        <p:nvPr/>
+      </p:nvGrpSpPr>
+      <p:grpSpPr>
+        <a:xfrm>
+          <a:off x="0" y="0"/>
+          <a:ext cx="0" cy="0"/>
+          <a:chOff x="0" y="0"/>
+          <a:chExt cx="0" cy="0"/>
+        </a:xfrm>
+      </p:grpSpPr>
+      <p:sp>
+        <p:nvSpPr>
+          <p:cNvPr id="2" name="Title 1">
+            <a:extLst>
+              <a:ext uri="{FF2B5EF4-FFF2-40B4-BE49-F238E27FC236}">
                 <a16:creationId xmlns:a16="http://schemas.microsoft.com/office/drawing/2014/main" id="{720C2576-357D-876A-70BB-664D14B59537}"/>
               </a:ext>
             </a:extLst>
@@ -10513,7 +10736,7 @@
 </p:sld>
 </file>
 
-<file path=ppt/slides/slide4.xml><?xml version="1.0" encoding="utf-8"?>
+<file path=ppt/slides/slide5.xml><?xml version="1.0" encoding="utf-8"?>
 <p:sld xmlns:a="http://schemas.openxmlformats.org/drawingml/2006/main" xmlns:r="http://schemas.openxmlformats.org/officeDocument/2006/relationships" xmlns:p="http://schemas.openxmlformats.org/presentationml/2006/main">
   <p:cSld>
     <p:spTree>
@@ -10654,7 +10877,7 @@
 </p:sld>
 </file>
 
-<file path=ppt/slides/slide5.xml><?xml version="1.0" encoding="utf-8"?>
+<file path=ppt/slides/slide6.xml><?xml version="1.0" encoding="utf-8"?>
 <p:sld xmlns:a="http://schemas.openxmlformats.org/drawingml/2006/main" xmlns:r="http://schemas.openxmlformats.org/officeDocument/2006/relationships" xmlns:p="http://schemas.openxmlformats.org/presentationml/2006/main">
   <p:cSld>
     <p:spTree>
@@ -10787,7 +11010,7 @@
 </p:sld>
 </file>
 
-<file path=ppt/slides/slide6.xml><?xml version="1.0" encoding="utf-8"?>
+<file path=ppt/slides/slide7.xml><?xml version="1.0" encoding="utf-8"?>
 <p:sld xmlns:a="http://schemas.openxmlformats.org/drawingml/2006/main" xmlns:r="http://schemas.openxmlformats.org/officeDocument/2006/relationships" xmlns:p="http://schemas.openxmlformats.org/presentationml/2006/main">
   <p:cSld>
     <p:spTree>
@@ -10920,7 +11143,7 @@
 </p:sld>
 </file>
 
-<file path=ppt/slides/slide7.xml><?xml version="1.0" encoding="utf-8"?>
+<file path=ppt/slides/slide8.xml><?xml version="1.0" encoding="utf-8"?>
 <p:sld xmlns:a="http://schemas.openxmlformats.org/drawingml/2006/main" xmlns:r="http://schemas.openxmlformats.org/officeDocument/2006/relationships" xmlns:p="http://schemas.openxmlformats.org/presentationml/2006/main">
   <p:cSld>
     <p:spTree>
@@ -11320,7 +11543,7 @@
 </p:sld>
 </file>
 
-<file path=ppt/slides/slide8.xml><?xml version="1.0" encoding="utf-8"?>
+<file path=ppt/slides/slide9.xml><?xml version="1.0" encoding="utf-8"?>
 <p:sld xmlns:a="http://schemas.openxmlformats.org/drawingml/2006/main" xmlns:r="http://schemas.openxmlformats.org/officeDocument/2006/relationships" xmlns:p="http://schemas.openxmlformats.org/presentationml/2006/main">
   <p:cSld>
     <p:spTree>
@@ -12029,139 +12252,6 @@
     <p:extLst>
       <p:ext uri="{BB962C8B-B14F-4D97-AF65-F5344CB8AC3E}">
         <p14:creationId xmlns:p14="http://schemas.microsoft.com/office/powerpoint/2010/main" val="2255730433"/>
-      </p:ext>
-    </p:extLst>
-  </p:cSld>
-  <p:clrMapOvr>
-    <a:masterClrMapping/>
-  </p:clrMapOvr>
-</p:sld>
-</file>
-
-<file path=ppt/slides/slide9.xml><?xml version="1.0" encoding="utf-8"?>
-<p:sld xmlns:a="http://schemas.openxmlformats.org/drawingml/2006/main" xmlns:r="http://schemas.openxmlformats.org/officeDocument/2006/relationships" xmlns:p="http://schemas.openxmlformats.org/presentationml/2006/main">
-  <p:cSld>
-    <p:spTree>
-      <p:nvGrpSpPr>
-        <p:cNvPr id="1" name="">
-          <a:extLst>
-            <a:ext uri="{FF2B5EF4-FFF2-40B4-BE49-F238E27FC236}">
-              <a16:creationId xmlns:a16="http://schemas.microsoft.com/office/drawing/2014/main" id="{F9812241-244B-055D-95DA-987DF4EAA2D5}"/>
-            </a:ext>
-          </a:extLst>
-        </p:cNvPr>
-        <p:cNvGrpSpPr/>
-        <p:nvPr/>
-      </p:nvGrpSpPr>
-      <p:grpSpPr>
-        <a:xfrm>
-          <a:off x="0" y="0"/>
-          <a:ext cx="0" cy="0"/>
-          <a:chOff x="0" y="0"/>
-          <a:chExt cx="0" cy="0"/>
-        </a:xfrm>
-      </p:grpSpPr>
-      <p:sp>
-        <p:nvSpPr>
-          <p:cNvPr id="2" name="Title 1">
-            <a:extLst>
-              <a:ext uri="{FF2B5EF4-FFF2-40B4-BE49-F238E27FC236}">
-                <a16:creationId xmlns:a16="http://schemas.microsoft.com/office/drawing/2014/main" id="{75FE6AA7-F871-9867-601A-1AAE31E9774B}"/>
-              </a:ext>
-            </a:extLst>
-          </p:cNvPr>
-          <p:cNvSpPr>
-            <a:spLocks noGrp="1"/>
-          </p:cNvSpPr>
-          <p:nvPr>
-            <p:ph type="title"/>
-          </p:nvPr>
-        </p:nvSpPr>
-        <p:spPr/>
-        <p:txBody>
-          <a:bodyPr/>
-          <a:lstStyle/>
-          <a:p>
-            <a:r>
-              <a:rPr lang="en-US" dirty="0"/>
-              <a:t>Modeling mindsets:</a:t>
-            </a:r>
-          </a:p>
-        </p:txBody>
-      </p:sp>
-      <p:sp>
-        <p:nvSpPr>
-          <p:cNvPr id="5" name="TextBox 4">
-            <a:extLst>
-              <a:ext uri="{FF2B5EF4-FFF2-40B4-BE49-F238E27FC236}">
-                <a16:creationId xmlns:a16="http://schemas.microsoft.com/office/drawing/2014/main" id="{0B1164BB-72D5-4A22-DFB6-60343F96D0CA}"/>
-              </a:ext>
-            </a:extLst>
-          </p:cNvPr>
-          <p:cNvSpPr txBox="1"/>
-          <p:nvPr/>
-        </p:nvSpPr>
-        <p:spPr>
-          <a:xfrm>
-            <a:off x="4537276" y="6488668"/>
-            <a:ext cx="8191983" cy="369332"/>
-          </a:xfrm>
-          <a:prstGeom prst="rect">
-            <a:avLst/>
-          </a:prstGeom>
-          <a:noFill/>
-        </p:spPr>
-        <p:txBody>
-          <a:bodyPr wrap="square">
-            <a:spAutoFit/>
-          </a:bodyPr>
-          <a:lstStyle/>
-          <a:p>
-            <a:r>
-              <a:rPr lang="en-US" dirty="0">
-                <a:hlinkClick r:id="rId3"/>
-              </a:rPr>
-              <a:t>Molnar, C. 2023. Modeling mindsets: the many cultures of learning from data.</a:t>
-            </a:r>
-            <a:endParaRPr lang="en-US" dirty="0"/>
-          </a:p>
-        </p:txBody>
-      </p:sp>
-      <p:pic>
-        <p:nvPicPr>
-          <p:cNvPr id="4" name="Picture 3">
-            <a:extLst>
-              <a:ext uri="{FF2B5EF4-FFF2-40B4-BE49-F238E27FC236}">
-                <a16:creationId xmlns:a16="http://schemas.microsoft.com/office/drawing/2014/main" id="{6F15411E-D06D-FD4C-7FF2-987BD7935E9A}"/>
-              </a:ext>
-            </a:extLst>
-          </p:cNvPr>
-          <p:cNvPicPr>
-            <a:picLocks noChangeAspect="1"/>
-          </p:cNvPicPr>
-          <p:nvPr/>
-        </p:nvPicPr>
-        <p:blipFill>
-          <a:blip r:embed="rId4"/>
-          <a:srcRect l="-14" r="105" b="11454"/>
-          <a:stretch>
-            <a:fillRect/>
-          </a:stretch>
-        </p:blipFill>
-        <p:spPr>
-          <a:xfrm>
-            <a:off x="2208628" y="1806292"/>
-            <a:ext cx="7765366" cy="3830580"/>
-          </a:xfrm>
-          <a:prstGeom prst="rect">
-            <a:avLst/>
-          </a:prstGeom>
-        </p:spPr>
-      </p:pic>
-    </p:spTree>
-    <p:extLst>
-      <p:ext uri="{BB962C8B-B14F-4D97-AF65-F5344CB8AC3E}">
-        <p14:creationId xmlns:p14="http://schemas.microsoft.com/office/powerpoint/2010/main" val="3401170566"/>
       </p:ext>
     </p:extLst>
   </p:cSld>

</xml_diff>